<commit_message>
Chapter 1: Updated with all 6 official graphics
PPT (11 slides):
- Core thesis
- Buyer Journey Compression
- Visibility Gap
- SEO to GEO
- New Awareness Stack
- Tiered Launch Model
- Pragmatic Funnel Map
- Three Clusters
- 10x Thesis
- CMO Perspective

Leave-behind PDF: 2 pages with all 6 figures
</commit_message>
<xml_diff>
--- a/dist/curriculum/chapter-01/chapter-01-sap.pptx
+++ b/dist/curriculum/chapter-01/chapter-01-sap.pptx
@@ -15,6 +15,7 @@
     <p:sldId id="263" r:id="rId14"/>
     <p:sldId id="264" r:id="rId15"/>
     <p:sldId id="265" r:id="rId16"/>
+    <p:sldId id="266" r:id="rId17"/>
   </p:sldIdLst>
   <p:sldSz cx="12191695" cy="6858000" type="screen4x3"/>
   <p:notesSz cx="6858000" cy="9144000"/>
@@ -3443,7 +3444,7 @@
             <a:avLst/>
           </a:prstGeom>
           <a:solidFill>
-            <a:srgbClr val="44546A"/>
+            <a:srgbClr val="ED7D31"/>
           </a:solidFill>
           <a:ln>
             <a:noFill/>
@@ -3502,7 +3503,7 @@
               </a:defRPr>
             </a:pPr>
             <a:r>
-              <a:t>CMO PERSPECTIVE</a:t>
+              <a:t>THE 10x THESIS</a:t>
             </a:r>
           </a:p>
         </p:txBody>
@@ -3515,8 +3516,8 @@
         </p:nvSpPr>
         <p:spPr>
           <a:xfrm>
-            <a:off x="457200" y="1097280"/>
-            <a:ext cx="11247120" cy="1645920"/>
+            <a:off x="457200" y="1188720"/>
+            <a:ext cx="11247120" cy="1828800"/>
           </a:xfrm>
           <a:prstGeom prst="rect">
             <a:avLst/>
@@ -3558,8 +3559,8 @@
         </p:nvSpPr>
         <p:spPr>
           <a:xfrm>
-            <a:off x="640080" y="1280160"/>
-            <a:ext cx="10881360" cy="1371600"/>
+            <a:off x="640080" y="1371600"/>
+            <a:ext cx="10881360" cy="1645920"/>
           </a:xfrm>
           <a:prstGeom prst="rect">
             <a:avLst/>
@@ -3573,7 +3574,7 @@
           <a:lstStyle/>
           <a:p>
             <a:pPr algn="ctr">
-              <a:defRPr sz="1400" b="0">
+              <a:defRPr sz="1500" b="0">
                 <a:solidFill>
                   <a:srgbClr val="44546A"/>
                 </a:solidFill>
@@ -3581,12 +3582,12 @@
               </a:defRPr>
             </a:pPr>
             <a:r>
-              <a:t>The conversation about AI inside marketing departments is almost entirely wrong. It's focused on efficiency — how to produce the same outputs with fewer people. That's a CFO question.</a:t>
+              <a:t>A PMM who automates 20 hours a week of Cluster One work and redirects that time into deeper competitive analysis, more thoughtful positioning, and genuine thought leadership will outperform one still manually updating battlecards.</a:t>
             </a:r>
             <a:br/>
             <a:br/>
             <a:r>
-              <a:t>The CMO question: how do we produce fundamentally different outputs?</a:t>
+              <a:t>Not by 20%. By a factor that justifies the title of this curriculum.</a:t>
             </a:r>
           </a:p>
         </p:txBody>
@@ -3599,7 +3600,7 @@
         </p:nvSpPr>
         <p:spPr>
           <a:xfrm>
-            <a:off x="457200" y="2926080"/>
+            <a:off x="457200" y="3291840"/>
             <a:ext cx="10972800" cy="457200"/>
           </a:xfrm>
           <a:prstGeom prst="rect">
@@ -3622,6 +3623,375 @@
               </a:defRPr>
             </a:pPr>
             <a:r>
+              <a:t>What "10x yourself" actually means:</a:t>
+            </a:r>
+          </a:p>
+        </p:txBody>
+      </p:sp>
+      <p:sp>
+        <p:nvSpPr>
+          <p:cNvPr id="7" name="TextBox 6"/>
+          <p:cNvSpPr txBox="1"/>
+          <p:nvPr/>
+        </p:nvSpPr>
+        <p:spPr>
+          <a:xfrm>
+            <a:off x="457200" y="3749039"/>
+            <a:ext cx="10972800" cy="457200"/>
+          </a:xfrm>
+          <a:prstGeom prst="rect">
+            <a:avLst/>
+          </a:prstGeom>
+          <a:noFill/>
+        </p:spPr>
+        <p:txBody>
+          <a:bodyPr wrap="square">
+            <a:spAutoFit/>
+          </a:bodyPr>
+          <a:lstStyle/>
+          <a:p>
+            <a:pPr algn="l">
+              <a:defRPr sz="1400" b="0">
+                <a:solidFill>
+                  <a:srgbClr val="8B0000"/>
+                </a:solidFill>
+                <a:latin typeface="Arial"/>
+              </a:defRPr>
+            </a:pPr>
+            <a:r>
+              <a:t>✗  NOT working ten times harder</a:t>
+            </a:r>
+          </a:p>
+        </p:txBody>
+      </p:sp>
+      <p:sp>
+        <p:nvSpPr>
+          <p:cNvPr id="8" name="TextBox 7"/>
+          <p:cNvSpPr txBox="1"/>
+          <p:nvPr/>
+        </p:nvSpPr>
+        <p:spPr>
+          <a:xfrm>
+            <a:off x="457200" y="4206240"/>
+            <a:ext cx="10972800" cy="457200"/>
+          </a:xfrm>
+          <a:prstGeom prst="rect">
+            <a:avLst/>
+          </a:prstGeom>
+          <a:noFill/>
+        </p:spPr>
+        <p:txBody>
+          <a:bodyPr wrap="square">
+            <a:spAutoFit/>
+          </a:bodyPr>
+          <a:lstStyle/>
+          <a:p>
+            <a:pPr algn="l">
+              <a:defRPr sz="1400" b="0">
+                <a:solidFill>
+                  <a:srgbClr val="8B0000"/>
+                </a:solidFill>
+                <a:latin typeface="Arial"/>
+              </a:defRPr>
+            </a:pPr>
+            <a:r>
+              <a:t>✗  NOT working ten times faster</a:t>
+            </a:r>
+          </a:p>
+        </p:txBody>
+      </p:sp>
+      <p:sp>
+        <p:nvSpPr>
+          <p:cNvPr id="9" name="TextBox 8"/>
+          <p:cNvSpPr txBox="1"/>
+          <p:nvPr/>
+        </p:nvSpPr>
+        <p:spPr>
+          <a:xfrm>
+            <a:off x="457200" y="4663440"/>
+            <a:ext cx="10972800" cy="457200"/>
+          </a:xfrm>
+          <a:prstGeom prst="rect">
+            <a:avLst/>
+          </a:prstGeom>
+          <a:noFill/>
+        </p:spPr>
+        <p:txBody>
+          <a:bodyPr wrap="square">
+            <a:spAutoFit/>
+          </a:bodyPr>
+          <a:lstStyle/>
+          <a:p>
+            <a:pPr algn="l">
+              <a:defRPr sz="1400" b="1">
+                <a:solidFill>
+                  <a:srgbClr val="70AD47"/>
+                </a:solidFill>
+                <a:latin typeface="Arial"/>
+              </a:defRPr>
+            </a:pPr>
+            <a:r>
+              <a:t>✓  Operating at a fundamentally different level of strategic impact</a:t>
+            </a:r>
+          </a:p>
+        </p:txBody>
+      </p:sp>
+      <p:sp>
+        <p:nvSpPr>
+          <p:cNvPr id="10" name="TextBox 9"/>
+          <p:cNvSpPr txBox="1"/>
+          <p:nvPr/>
+        </p:nvSpPr>
+        <p:spPr>
+          <a:xfrm>
+            <a:off x="457200" y="5303520"/>
+            <a:ext cx="10972800" cy="914400"/>
+          </a:xfrm>
+          <a:prstGeom prst="rect">
+            <a:avLst/>
+          </a:prstGeom>
+          <a:noFill/>
+        </p:spPr>
+        <p:txBody>
+          <a:bodyPr wrap="square">
+            <a:spAutoFit/>
+          </a:bodyPr>
+          <a:lstStyle/>
+          <a:p>
+            <a:pPr algn="ctr">
+              <a:defRPr sz="1400" b="1">
+                <a:solidFill>
+                  <a:srgbClr val="44546A"/>
+                </a:solidFill>
+                <a:latin typeface="Arial"/>
+              </a:defRPr>
+            </a:pPr>
+            <a:r>
+              <a:t>You've offloaded the mechanical work to machines built for it —</a:t>
+            </a:r>
+            <a:br/>
+            <a:r>
+              <a:t>and you're finally free to do the work that only a human can do.</a:t>
+            </a:r>
+          </a:p>
+        </p:txBody>
+      </p:sp>
+    </p:spTree>
+  </p:cSld>
+  <p:clrMapOvr>
+    <a:masterClrMapping/>
+  </p:clrMapOvr>
+</p:sld>
+</file>
+
+<file path=ppt/slides/slide11.xml><?xml version="1.0" encoding="utf-8"?>
+<p:sld xmlns:a="http://schemas.openxmlformats.org/drawingml/2006/main" xmlns:p="http://schemas.openxmlformats.org/presentationml/2006/main" xmlns:r="http://schemas.openxmlformats.org/officeDocument/2006/relationships">
+  <p:cSld>
+    <p:spTree>
+      <p:nvGrpSpPr>
+        <p:cNvPr id="1" name=""/>
+        <p:cNvGrpSpPr/>
+        <p:nvPr/>
+      </p:nvGrpSpPr>
+      <p:grpSpPr/>
+      <p:sp>
+        <p:nvSpPr>
+          <p:cNvPr id="2" name="Rectangle 1"/>
+          <p:cNvSpPr/>
+          <p:nvPr/>
+        </p:nvSpPr>
+        <p:spPr>
+          <a:xfrm>
+            <a:off x="0" y="0"/>
+            <a:ext cx="12191695" cy="914400"/>
+          </a:xfrm>
+          <a:prstGeom prst="rect">
+            <a:avLst/>
+          </a:prstGeom>
+          <a:solidFill>
+            <a:srgbClr val="44546A"/>
+          </a:solidFill>
+          <a:ln>
+            <a:noFill/>
+          </a:ln>
+        </p:spPr>
+        <p:style>
+          <a:lnRef idx="1">
+            <a:schemeClr val="accent1"/>
+          </a:lnRef>
+          <a:fillRef idx="3">
+            <a:schemeClr val="accent1"/>
+          </a:fillRef>
+          <a:effectRef idx="2">
+            <a:schemeClr val="accent1"/>
+          </a:effectRef>
+          <a:fontRef idx="minor">
+            <a:schemeClr val="lt1"/>
+          </a:fontRef>
+        </p:style>
+        <p:txBody>
+          <a:bodyPr rtlCol="0" anchor="ctr"/>
+          <a:lstStyle/>
+          <a:p>
+            <a:pPr algn="ctr"/>
+          </a:p>
+        </p:txBody>
+      </p:sp>
+      <p:sp>
+        <p:nvSpPr>
+          <p:cNvPr id="3" name="TextBox 2"/>
+          <p:cNvSpPr txBox="1"/>
+          <p:nvPr/>
+        </p:nvSpPr>
+        <p:spPr>
+          <a:xfrm>
+            <a:off x="457200" y="228600"/>
+            <a:ext cx="10972800" cy="457200"/>
+          </a:xfrm>
+          <a:prstGeom prst="rect">
+            <a:avLst/>
+          </a:prstGeom>
+          <a:noFill/>
+        </p:spPr>
+        <p:txBody>
+          <a:bodyPr wrap="square">
+            <a:spAutoFit/>
+          </a:bodyPr>
+          <a:lstStyle/>
+          <a:p>
+            <a:pPr algn="l">
+              <a:defRPr sz="2000" b="1">
+                <a:solidFill>
+                  <a:srgbClr val="FFFFFF"/>
+                </a:solidFill>
+                <a:latin typeface="Arial"/>
+              </a:defRPr>
+            </a:pPr>
+            <a:r>
+              <a:t>CMO PERSPECTIVE</a:t>
+            </a:r>
+          </a:p>
+        </p:txBody>
+      </p:sp>
+      <p:sp>
+        <p:nvSpPr>
+          <p:cNvPr id="4" name="Rectangle 3"/>
+          <p:cNvSpPr/>
+          <p:nvPr/>
+        </p:nvSpPr>
+        <p:spPr>
+          <a:xfrm>
+            <a:off x="457200" y="1097280"/>
+            <a:ext cx="11247120" cy="1463040"/>
+          </a:xfrm>
+          <a:prstGeom prst="rect">
+            <a:avLst/>
+          </a:prstGeom>
+          <a:solidFill>
+            <a:srgbClr val="E7E6E6"/>
+          </a:solidFill>
+          <a:ln>
+            <a:noFill/>
+          </a:ln>
+        </p:spPr>
+        <p:style>
+          <a:lnRef idx="1">
+            <a:schemeClr val="accent1"/>
+          </a:lnRef>
+          <a:fillRef idx="3">
+            <a:schemeClr val="accent1"/>
+          </a:fillRef>
+          <a:effectRef idx="2">
+            <a:schemeClr val="accent1"/>
+          </a:effectRef>
+          <a:fontRef idx="minor">
+            <a:schemeClr val="lt1"/>
+          </a:fontRef>
+        </p:style>
+        <p:txBody>
+          <a:bodyPr rtlCol="0" anchor="ctr"/>
+          <a:lstStyle/>
+          <a:p>
+            <a:pPr algn="ctr"/>
+          </a:p>
+        </p:txBody>
+      </p:sp>
+      <p:sp>
+        <p:nvSpPr>
+          <p:cNvPr id="5" name="TextBox 4"/>
+          <p:cNvSpPr txBox="1"/>
+          <p:nvPr/>
+        </p:nvSpPr>
+        <p:spPr>
+          <a:xfrm>
+            <a:off x="640080" y="1280160"/>
+            <a:ext cx="10881360" cy="1280160"/>
+          </a:xfrm>
+          <a:prstGeom prst="rect">
+            <a:avLst/>
+          </a:prstGeom>
+          <a:noFill/>
+        </p:spPr>
+        <p:txBody>
+          <a:bodyPr wrap="square">
+            <a:spAutoFit/>
+          </a:bodyPr>
+          <a:lstStyle/>
+          <a:p>
+            <a:pPr algn="ctr">
+              <a:defRPr sz="1400" b="0">
+                <a:solidFill>
+                  <a:srgbClr val="44546A"/>
+                </a:solidFill>
+                <a:latin typeface="Arial"/>
+              </a:defRPr>
+            </a:pPr>
+            <a:r>
+              <a:t>The conversation about AI inside marketing departments is almost entirely wrong.</a:t>
+            </a:r>
+            <a:br/>
+            <a:r>
+              <a:t>It's focused on efficiency — that's a CFO question.</a:t>
+            </a:r>
+            <a:br/>
+            <a:br/>
+            <a:r>
+              <a:t>The CMO question: how do we produce fundamentally different outputs?</a:t>
+            </a:r>
+          </a:p>
+        </p:txBody>
+      </p:sp>
+      <p:sp>
+        <p:nvSpPr>
+          <p:cNvPr id="6" name="TextBox 5"/>
+          <p:cNvSpPr txBox="1"/>
+          <p:nvPr/>
+        </p:nvSpPr>
+        <p:spPr>
+          <a:xfrm>
+            <a:off x="457200" y="2743200"/>
+            <a:ext cx="10972800" cy="457200"/>
+          </a:xfrm>
+          <a:prstGeom prst="rect">
+            <a:avLst/>
+          </a:prstGeom>
+          <a:noFill/>
+        </p:spPr>
+        <p:txBody>
+          <a:bodyPr wrap="square">
+            <a:spAutoFit/>
+          </a:bodyPr>
+          <a:lstStyle/>
+          <a:p>
+            <a:pPr algn="l">
+              <a:defRPr sz="1400" b="1">
+                <a:solidFill>
+                  <a:srgbClr val="44546A"/>
+                </a:solidFill>
+                <a:latin typeface="Arial"/>
+              </a:defRPr>
+            </a:pPr>
+            <a:r>
               <a:t>KEY TAKEAWAYS</a:t>
             </a:r>
           </a:p>
@@ -3635,7 +4005,7 @@
         </p:nvSpPr>
         <p:spPr>
           <a:xfrm>
-            <a:off x="457200" y="3383280"/>
+            <a:off x="457200" y="3200400"/>
             <a:ext cx="11247120" cy="457200"/>
           </a:xfrm>
           <a:prstGeom prst="rect">
@@ -3678,7 +4048,7 @@
         </p:nvSpPr>
         <p:spPr>
           <a:xfrm>
-            <a:off x="640080" y="3474720"/>
+            <a:off x="640080" y="3291840"/>
             <a:ext cx="10881360" cy="365760"/>
           </a:xfrm>
           <a:prstGeom prst="rect">
@@ -3701,7 +4071,7 @@
               </a:defRPr>
             </a:pPr>
             <a:r>
-              <a:t>The agentic shift is a structural transformation, not just a toolkit upgrade</a:t>
+              <a:t>The agentic shift is a structural transformation, not a toolkit upgrade</a:t>
             </a:r>
           </a:p>
         </p:txBody>
@@ -3714,7 +4084,7 @@
         </p:nvSpPr>
         <p:spPr>
           <a:xfrm>
-            <a:off x="457200" y="3886200"/>
+            <a:off x="457200" y="3703320"/>
             <a:ext cx="11247120" cy="457200"/>
           </a:xfrm>
           <a:prstGeom prst="rect">
@@ -3757,7 +4127,7 @@
         </p:nvSpPr>
         <p:spPr>
           <a:xfrm>
-            <a:off x="640080" y="3977639"/>
+            <a:off x="640080" y="3794760"/>
             <a:ext cx="10881360" cy="365760"/>
           </a:xfrm>
           <a:prstGeom prst="rect">
@@ -3793,7 +4163,7 @@
         </p:nvSpPr>
         <p:spPr>
           <a:xfrm>
-            <a:off x="457200" y="4389120"/>
+            <a:off x="457200" y="4206240"/>
             <a:ext cx="11247120" cy="457200"/>
           </a:xfrm>
           <a:prstGeom prst="rect">
@@ -3836,7 +4206,7 @@
         </p:nvSpPr>
         <p:spPr>
           <a:xfrm>
-            <a:off x="640080" y="4480560"/>
+            <a:off x="640080" y="4297680"/>
             <a:ext cx="10881360" cy="365760"/>
           </a:xfrm>
           <a:prstGeom prst="rect">
@@ -3872,7 +4242,7 @@
         </p:nvSpPr>
         <p:spPr>
           <a:xfrm>
-            <a:off x="457200" y="4892040"/>
+            <a:off x="457200" y="4709160"/>
             <a:ext cx="11247120" cy="457200"/>
           </a:xfrm>
           <a:prstGeom prst="rect">
@@ -3915,7 +4285,7 @@
         </p:nvSpPr>
         <p:spPr>
           <a:xfrm>
-            <a:off x="640080" y="4983480"/>
+            <a:off x="640080" y="4800600"/>
             <a:ext cx="10881360" cy="365760"/>
           </a:xfrm>
           <a:prstGeom prst="rect">
@@ -3951,7 +4321,7 @@
         </p:nvSpPr>
         <p:spPr>
           <a:xfrm>
-            <a:off x="457200" y="5394960"/>
+            <a:off x="457200" y="5212080"/>
             <a:ext cx="11247120" cy="457200"/>
           </a:xfrm>
           <a:prstGeom prst="rect">
@@ -3994,7 +4364,7 @@
         </p:nvSpPr>
         <p:spPr>
           <a:xfrm>
-            <a:off x="640080" y="5486400"/>
+            <a:off x="640080" y="5303520"/>
             <a:ext cx="10881360" cy="365760"/>
           </a:xfrm>
           <a:prstGeom prst="rect">
@@ -4193,522 +4563,21 @@
               </a:defRPr>
             </a:pPr>
             <a:r>
-              <a:t>THE STORY OF SARAH</a:t>
-            </a:r>
-          </a:p>
-        </p:txBody>
-      </p:sp>
-      <p:sp>
-        <p:nvSpPr>
-          <p:cNvPr id="4" name="TextBox 3"/>
-          <p:cNvSpPr txBox="1"/>
-          <p:nvPr/>
-        </p:nvSpPr>
-        <p:spPr>
-          <a:xfrm>
-            <a:off x="457200" y="1097280"/>
-            <a:ext cx="11247120" cy="1097280"/>
-          </a:xfrm>
-          <a:prstGeom prst="rect">
-            <a:avLst/>
-          </a:prstGeom>
-          <a:noFill/>
-        </p:spPr>
-        <p:txBody>
-          <a:bodyPr wrap="square">
-            <a:spAutoFit/>
-          </a:bodyPr>
-          <a:lstStyle/>
-          <a:p>
-            <a:pPr algn="l">
-              <a:defRPr sz="1600" b="0">
-                <a:solidFill>
-                  <a:srgbClr val="44546A"/>
-                </a:solidFill>
-                <a:latin typeface="Arial"/>
-              </a:defRPr>
-            </a:pPr>
-            <a:r>
-              <a:t>Sometime in late 2024, a product marketer noticed something strange in her pipeline data...</a:t>
-            </a:r>
-          </a:p>
-        </p:txBody>
-      </p:sp>
-      <p:sp>
-        <p:nvSpPr>
-          <p:cNvPr id="5" name="Rectangle 4"/>
+              <a:t>CORE THESIS</a:t>
+            </a:r>
+          </a:p>
+        </p:txBody>
+      </p:sp>
+      <p:sp>
+        <p:nvSpPr>
+          <p:cNvPr id="4" name="Rectangle 3"/>
           <p:cNvSpPr/>
           <p:nvPr/>
         </p:nvSpPr>
         <p:spPr>
           <a:xfrm>
-            <a:off x="457200" y="2286000"/>
-            <a:ext cx="3657600" cy="2560320"/>
-          </a:xfrm>
-          <a:prstGeom prst="rect">
-            <a:avLst/>
-          </a:prstGeom>
-          <a:solidFill>
-            <a:srgbClr val="4472C4"/>
-          </a:solidFill>
-          <a:ln>
-            <a:noFill/>
-          </a:ln>
-        </p:spPr>
-        <p:style>
-          <a:lnRef idx="1">
-            <a:schemeClr val="accent1"/>
-          </a:lnRef>
-          <a:fillRef idx="3">
-            <a:schemeClr val="accent1"/>
-          </a:fillRef>
-          <a:effectRef idx="2">
-            <a:schemeClr val="accent1"/>
-          </a:effectRef>
-          <a:fontRef idx="minor">
-            <a:schemeClr val="lt1"/>
-          </a:fontRef>
-        </p:style>
-        <p:txBody>
-          <a:bodyPr rtlCol="0" anchor="ctr"/>
-          <a:lstStyle/>
-          <a:p>
-            <a:pPr algn="ctr"/>
-          </a:p>
-        </p:txBody>
-      </p:sp>
-      <p:sp>
-        <p:nvSpPr>
-          <p:cNvPr id="6" name="TextBox 5"/>
-          <p:cNvSpPr txBox="1"/>
-          <p:nvPr/>
-        </p:nvSpPr>
-        <p:spPr>
-          <a:xfrm>
-            <a:off x="640080" y="2468880"/>
-            <a:ext cx="548640" cy="457200"/>
-          </a:xfrm>
-          <a:prstGeom prst="rect">
-            <a:avLst/>
-          </a:prstGeom>
-          <a:noFill/>
-        </p:spPr>
-        <p:txBody>
-          <a:bodyPr wrap="square">
-            <a:spAutoFit/>
-          </a:bodyPr>
-          <a:lstStyle/>
-          <a:p>
-            <a:pPr algn="l">
-              <a:defRPr sz="2400" b="1">
-                <a:solidFill>
-                  <a:srgbClr val="FFFFFF"/>
-                </a:solidFill>
-                <a:latin typeface="Arial"/>
-              </a:defRPr>
-            </a:pPr>
-            <a:r>
-              <a:t>1</a:t>
-            </a:r>
-          </a:p>
-        </p:txBody>
-      </p:sp>
-      <p:sp>
-        <p:nvSpPr>
-          <p:cNvPr id="7" name="TextBox 6"/>
-          <p:cNvSpPr txBox="1"/>
-          <p:nvPr/>
-        </p:nvSpPr>
-        <p:spPr>
-          <a:xfrm>
-            <a:off x="640080" y="2926080"/>
-            <a:ext cx="3291840" cy="548640"/>
-          </a:xfrm>
-          <a:prstGeom prst="rect">
-            <a:avLst/>
-          </a:prstGeom>
-          <a:noFill/>
-        </p:spPr>
-        <p:txBody>
-          <a:bodyPr wrap="square">
-            <a:spAutoFit/>
-          </a:bodyPr>
-          <a:lstStyle/>
-          <a:p>
-            <a:pPr algn="l">
-              <a:defRPr sz="1600" b="1">
-                <a:solidFill>
-                  <a:srgbClr val="FFFFFF"/>
-                </a:solidFill>
-                <a:latin typeface="Arial"/>
-              </a:defRPr>
-            </a:pPr>
-            <a:r>
-              <a:t>Traffic Up, Forms Down</a:t>
-            </a:r>
-          </a:p>
-        </p:txBody>
-      </p:sp>
-      <p:sp>
-        <p:nvSpPr>
-          <p:cNvPr id="8" name="TextBox 7"/>
-          <p:cNvSpPr txBox="1"/>
-          <p:nvPr/>
-        </p:nvSpPr>
-        <p:spPr>
-          <a:xfrm>
-            <a:off x="640080" y="3474720"/>
-            <a:ext cx="3291840" cy="1188720"/>
-          </a:xfrm>
-          <a:prstGeom prst="rect">
-            <a:avLst/>
-          </a:prstGeom>
-          <a:noFill/>
-        </p:spPr>
-        <p:txBody>
-          <a:bodyPr wrap="square">
-            <a:spAutoFit/>
-          </a:bodyPr>
-          <a:lstStyle/>
-          <a:p>
-            <a:pPr algn="l">
-              <a:defRPr sz="1200" b="0">
-                <a:solidFill>
-                  <a:srgbClr val="FFFFFF"/>
-                </a:solidFill>
-                <a:latin typeface="Arial"/>
-              </a:defRPr>
-            </a:pPr>
-            <a:r>
-              <a:t>More people visiting product pages,</a:t>
-            </a:r>
-            <a:br/>
-            <a:r>
-              <a:t>fewer downloading white papers</a:t>
-            </a:r>
-          </a:p>
-        </p:txBody>
-      </p:sp>
-      <p:sp>
-        <p:nvSpPr>
-          <p:cNvPr id="9" name="Rectangle 8"/>
-          <p:cNvSpPr/>
-          <p:nvPr/>
-        </p:nvSpPr>
-        <p:spPr>
-          <a:xfrm>
-            <a:off x="4297680" y="2286000"/>
-            <a:ext cx="3657600" cy="2560320"/>
-          </a:xfrm>
-          <a:prstGeom prst="rect">
-            <a:avLst/>
-          </a:prstGeom>
-          <a:solidFill>
-            <a:srgbClr val="5B9BD5"/>
-          </a:solidFill>
-          <a:ln>
-            <a:noFill/>
-          </a:ln>
-        </p:spPr>
-        <p:style>
-          <a:lnRef idx="1">
-            <a:schemeClr val="accent1"/>
-          </a:lnRef>
-          <a:fillRef idx="3">
-            <a:schemeClr val="accent1"/>
-          </a:fillRef>
-          <a:effectRef idx="2">
-            <a:schemeClr val="accent1"/>
-          </a:effectRef>
-          <a:fontRef idx="minor">
-            <a:schemeClr val="lt1"/>
-          </a:fontRef>
-        </p:style>
-        <p:txBody>
-          <a:bodyPr rtlCol="0" anchor="ctr"/>
-          <a:lstStyle/>
-          <a:p>
-            <a:pPr algn="ctr"/>
-          </a:p>
-        </p:txBody>
-      </p:sp>
-      <p:sp>
-        <p:nvSpPr>
-          <p:cNvPr id="10" name="TextBox 9"/>
-          <p:cNvSpPr txBox="1"/>
-          <p:nvPr/>
-        </p:nvSpPr>
-        <p:spPr>
-          <a:xfrm>
-            <a:off x="4480560" y="2468880"/>
-            <a:ext cx="548640" cy="457200"/>
-          </a:xfrm>
-          <a:prstGeom prst="rect">
-            <a:avLst/>
-          </a:prstGeom>
-          <a:noFill/>
-        </p:spPr>
-        <p:txBody>
-          <a:bodyPr wrap="square">
-            <a:spAutoFit/>
-          </a:bodyPr>
-          <a:lstStyle/>
-          <a:p>
-            <a:pPr algn="l">
-              <a:defRPr sz="2400" b="1">
-                <a:solidFill>
-                  <a:srgbClr val="FFFFFF"/>
-                </a:solidFill>
-                <a:latin typeface="Arial"/>
-              </a:defRPr>
-            </a:pPr>
-            <a:r>
-              <a:t>2</a:t>
-            </a:r>
-          </a:p>
-        </p:txBody>
-      </p:sp>
-      <p:sp>
-        <p:nvSpPr>
-          <p:cNvPr id="11" name="TextBox 10"/>
-          <p:cNvSpPr txBox="1"/>
-          <p:nvPr/>
-        </p:nvSpPr>
-        <p:spPr>
-          <a:xfrm>
-            <a:off x="4480560" y="2926080"/>
-            <a:ext cx="3291840" cy="548640"/>
-          </a:xfrm>
-          <a:prstGeom prst="rect">
-            <a:avLst/>
-          </a:prstGeom>
-          <a:noFill/>
-        </p:spPr>
-        <p:txBody>
-          <a:bodyPr wrap="square">
-            <a:spAutoFit/>
-          </a:bodyPr>
-          <a:lstStyle/>
-          <a:p>
-            <a:pPr algn="l">
-              <a:defRPr sz="1600" b="1">
-                <a:solidFill>
-                  <a:srgbClr val="FFFFFF"/>
-                </a:solidFill>
-                <a:latin typeface="Arial"/>
-              </a:defRPr>
-            </a:pPr>
-            <a:r>
-              <a:t>Prospects Knew Too Much</a:t>
-            </a:r>
-          </a:p>
-        </p:txBody>
-      </p:sp>
-      <p:sp>
-        <p:nvSpPr>
-          <p:cNvPr id="12" name="TextBox 11"/>
-          <p:cNvSpPr txBox="1"/>
-          <p:nvPr/>
-        </p:nvSpPr>
-        <p:spPr>
-          <a:xfrm>
-            <a:off x="4480560" y="3474720"/>
-            <a:ext cx="3291840" cy="1188720"/>
-          </a:xfrm>
-          <a:prstGeom prst="rect">
-            <a:avLst/>
-          </a:prstGeom>
-          <a:noFill/>
-        </p:spPr>
-        <p:txBody>
-          <a:bodyPr wrap="square">
-            <a:spAutoFit/>
-          </a:bodyPr>
-          <a:lstStyle/>
-          <a:p>
-            <a:pPr algn="l">
-              <a:defRPr sz="1200" b="0">
-                <a:solidFill>
-                  <a:srgbClr val="FFFFFF"/>
-                </a:solidFill>
-                <a:latin typeface="Arial"/>
-              </a:defRPr>
-            </a:pPr>
-            <a:r>
-              <a:t>Showing up to calls knowing competitive</a:t>
-            </a:r>
-            <a:br/>
-            <a:r>
-              <a:t>pricing and technical limitations</a:t>
-            </a:r>
-          </a:p>
-        </p:txBody>
-      </p:sp>
-      <p:sp>
-        <p:nvSpPr>
-          <p:cNvPr id="13" name="Rectangle 12"/>
-          <p:cNvSpPr/>
-          <p:nvPr/>
-        </p:nvSpPr>
-        <p:spPr>
-          <a:xfrm>
-            <a:off x="8138160" y="2286000"/>
-            <a:ext cx="3657600" cy="2560320"/>
-          </a:xfrm>
-          <a:prstGeom prst="rect">
-            <a:avLst/>
-          </a:prstGeom>
-          <a:solidFill>
-            <a:srgbClr val="ED7D31"/>
-          </a:solidFill>
-          <a:ln>
-            <a:noFill/>
-          </a:ln>
-        </p:spPr>
-        <p:style>
-          <a:lnRef idx="1">
-            <a:schemeClr val="accent1"/>
-          </a:lnRef>
-          <a:fillRef idx="3">
-            <a:schemeClr val="accent1"/>
-          </a:fillRef>
-          <a:effectRef idx="2">
-            <a:schemeClr val="accent1"/>
-          </a:effectRef>
-          <a:fontRef idx="minor">
-            <a:schemeClr val="lt1"/>
-          </a:fontRef>
-        </p:style>
-        <p:txBody>
-          <a:bodyPr rtlCol="0" anchor="ctr"/>
-          <a:lstStyle/>
-          <a:p>
-            <a:pPr algn="ctr"/>
-          </a:p>
-        </p:txBody>
-      </p:sp>
-      <p:sp>
-        <p:nvSpPr>
-          <p:cNvPr id="14" name="TextBox 13"/>
-          <p:cNvSpPr txBox="1"/>
-          <p:nvPr/>
-        </p:nvSpPr>
-        <p:spPr>
-          <a:xfrm>
-            <a:off x="8321040" y="2468880"/>
-            <a:ext cx="548640" cy="457200"/>
-          </a:xfrm>
-          <a:prstGeom prst="rect">
-            <a:avLst/>
-          </a:prstGeom>
-          <a:noFill/>
-        </p:spPr>
-        <p:txBody>
-          <a:bodyPr wrap="square">
-            <a:spAutoFit/>
-          </a:bodyPr>
-          <a:lstStyle/>
-          <a:p>
-            <a:pPr algn="l">
-              <a:defRPr sz="2400" b="1">
-                <a:solidFill>
-                  <a:srgbClr val="FFFFFF"/>
-                </a:solidFill>
-                <a:latin typeface="Arial"/>
-              </a:defRPr>
-            </a:pPr>
-            <a:r>
-              <a:t>3</a:t>
-            </a:r>
-          </a:p>
-        </p:txBody>
-      </p:sp>
-      <p:sp>
-        <p:nvSpPr>
-          <p:cNvPr id="15" name="TextBox 14"/>
-          <p:cNvSpPr txBox="1"/>
-          <p:nvPr/>
-        </p:nvSpPr>
-        <p:spPr>
-          <a:xfrm>
-            <a:off x="8321040" y="2926080"/>
-            <a:ext cx="3291840" cy="548640"/>
-          </a:xfrm>
-          <a:prstGeom prst="rect">
-            <a:avLst/>
-          </a:prstGeom>
-          <a:noFill/>
-        </p:spPr>
-        <p:txBody>
-          <a:bodyPr wrap="square">
-            <a:spAutoFit/>
-          </a:bodyPr>
-          <a:lstStyle/>
-          <a:p>
-            <a:pPr algn="l">
-              <a:defRPr sz="1600" b="1">
-                <a:solidFill>
-                  <a:srgbClr val="FFFFFF"/>
-                </a:solidFill>
-                <a:latin typeface="Arial"/>
-              </a:defRPr>
-            </a:pPr>
-            <a:r>
-              <a:t>Deals Closed in 3 Weeks</a:t>
-            </a:r>
-          </a:p>
-        </p:txBody>
-      </p:sp>
-      <p:sp>
-        <p:nvSpPr>
-          <p:cNvPr id="16" name="TextBox 15"/>
-          <p:cNvSpPr txBox="1"/>
-          <p:nvPr/>
-        </p:nvSpPr>
-        <p:spPr>
-          <a:xfrm>
-            <a:off x="8321040" y="3474720"/>
-            <a:ext cx="3291840" cy="1188720"/>
-          </a:xfrm>
-          <a:prstGeom prst="rect">
-            <a:avLst/>
-          </a:prstGeom>
-          <a:noFill/>
-        </p:spPr>
-        <p:txBody>
-          <a:bodyPr wrap="square">
-            <a:spAutoFit/>
-          </a:bodyPr>
-          <a:lstStyle/>
-          <a:p>
-            <a:pPr algn="l">
-              <a:defRPr sz="1200" b="0">
-                <a:solidFill>
-                  <a:srgbClr val="FFFFFF"/>
-                </a:solidFill>
-                <a:latin typeface="Arial"/>
-              </a:defRPr>
-            </a:pPr>
-            <a:r>
-              <a:t>Typical cycle was 11 weeks.</a:t>
-            </a:r>
-            <a:br/>
-            <a:r>
-              <a:t>Two enterprise deals closed in under 3.</a:t>
-            </a:r>
-          </a:p>
-        </p:txBody>
-      </p:sp>
-      <p:sp>
-        <p:nvSpPr>
-          <p:cNvPr id="17" name="Rectangle 16"/>
-          <p:cNvSpPr/>
-          <p:nvPr/>
-        </p:nvSpPr>
-        <p:spPr>
-          <a:xfrm>
-            <a:off x="457200" y="5120640"/>
-            <a:ext cx="11247120" cy="1188720"/>
+            <a:off x="457200" y="1371600"/>
+            <a:ext cx="11247120" cy="2743200"/>
           </a:xfrm>
           <a:prstGeom prst="rect">
             <a:avLst/>
@@ -4744,14 +4613,14 @@
       </p:sp>
       <p:sp>
         <p:nvSpPr>
-          <p:cNvPr id="18" name="TextBox 17"/>
+          <p:cNvPr id="5" name="TextBox 4"/>
           <p:cNvSpPr txBox="1"/>
           <p:nvPr/>
         </p:nvSpPr>
         <p:spPr>
           <a:xfrm>
-            <a:off x="640080" y="5303520"/>
-            <a:ext cx="10881360" cy="914400"/>
+            <a:off x="731520" y="1645920"/>
+            <a:ext cx="10698480" cy="2286000"/>
           </a:xfrm>
           <a:prstGeom prst="rect">
             <a:avLst/>
@@ -4764,8 +4633,66 @@
           </a:bodyPr>
           <a:lstStyle/>
           <a:p>
+            <a:pPr algn="ctr">
+              <a:defRPr sz="1600" b="0">
+                <a:solidFill>
+                  <a:srgbClr val="44546A"/>
+                </a:solidFill>
+                <a:latin typeface="Arial"/>
+              </a:defRPr>
+            </a:pPr>
+            <a:r>
+              <a:t>The agentic era didn't accelerate the old B2B playbook — it ended it.</a:t>
+            </a:r>
+            <a:br/>
+            <a:br/>
+            <a:r>
+              <a:t>Product lifecycles now run in continuous deployment, not quarterly releases.</a:t>
+            </a:r>
+            <a:br/>
+            <a:r>
+              <a:t>Buyers consume content through AI intermediaries, not your website.</a:t>
+            </a:r>
+            <a:br/>
+            <a:r>
+              <a:t>GEO has replaced SEO. The funnel is no longer a funnel.</a:t>
+            </a:r>
+            <a:br/>
+            <a:br/>
+            <a:r>
+              <a:t>The PMM who survives this transition is not the one who learned to prompt faster —</a:t>
+            </a:r>
+            <a:br/>
+            <a:r>
+              <a:t>it's the one who understood what changed and why.</a:t>
+            </a:r>
+          </a:p>
+        </p:txBody>
+      </p:sp>
+      <p:sp>
+        <p:nvSpPr>
+          <p:cNvPr id="6" name="TextBox 5"/>
+          <p:cNvSpPr txBox="1"/>
+          <p:nvPr/>
+        </p:nvSpPr>
+        <p:spPr>
+          <a:xfrm>
+            <a:off x="457200" y="4572000"/>
+            <a:ext cx="11247120" cy="1371600"/>
+          </a:xfrm>
+          <a:prstGeom prst="rect">
+            <a:avLst/>
+          </a:prstGeom>
+          <a:noFill/>
+        </p:spPr>
+        <p:txBody>
+          <a:bodyPr wrap="square">
+            <a:spAutoFit/>
+          </a:bodyPr>
+          <a:lstStyle/>
+          <a:p>
             <a:pPr algn="l">
-              <a:defRPr sz="1400" b="0">
+              <a:defRPr sz="1200" b="1">
                 <a:solidFill>
                   <a:srgbClr val="44546A"/>
                 </a:solidFill>
@@ -4773,7 +4700,59 @@
               </a:defRPr>
             </a:pPr>
             <a:r>
-              <a:t>What had changed: her buyers had started using AI agents to do the research, comparison shopping, and vendor pre-qualification that used to take human buying committees weeks.</a:t>
+              <a:t>This chapter establishes:</a:t>
+            </a:r>
+          </a:p>
+          <a:p>
+            <a:pPr>
+              <a:defRPr sz="1200">
+                <a:solidFill>
+                  <a:srgbClr val="44546A"/>
+                </a:solidFill>
+                <a:latin typeface="Arial"/>
+              </a:defRPr>
+            </a:pPr>
+            <a:r>
+              <a:t>• The three eras of enterprise data</a:t>
+            </a:r>
+          </a:p>
+          <a:p>
+            <a:pPr>
+              <a:defRPr sz="1200">
+                <a:solidFill>
+                  <a:srgbClr val="44546A"/>
+                </a:solidFill>
+                <a:latin typeface="Arial"/>
+              </a:defRPr>
+            </a:pPr>
+            <a:r>
+              <a:t>• The visibility gap</a:t>
+            </a:r>
+          </a:p>
+          <a:p>
+            <a:pPr>
+              <a:defRPr sz="1200">
+                <a:solidFill>
+                  <a:srgbClr val="44546A"/>
+                </a:solidFill>
+                <a:latin typeface="Arial"/>
+              </a:defRPr>
+            </a:pPr>
+            <a:r>
+              <a:t>• From SEO to GEO</a:t>
+            </a:r>
+          </a:p>
+          <a:p>
+            <a:pPr>
+              <a:defRPr sz="1200">
+                <a:solidFill>
+                  <a:srgbClr val="44546A"/>
+                </a:solidFill>
+                <a:latin typeface="Arial"/>
+              </a:defRPr>
+            </a:pPr>
+            <a:r>
+              <a:t>• The Pragmatic 37 reimagined</a:t>
             </a:r>
           </a:p>
         </p:txBody>
@@ -4805,7 +4784,7 @@
         <p:spPr>
           <a:xfrm>
             <a:off x="0" y="0"/>
-            <a:ext cx="12191695" cy="914400"/>
+            <a:ext cx="12191695" cy="731520"/>
           </a:xfrm>
           <a:prstGeom prst="rect">
             <a:avLst/>
@@ -4847,7 +4826,7 @@
         </p:nvSpPr>
         <p:spPr>
           <a:xfrm>
-            <a:off x="457200" y="228600"/>
+            <a:off x="457200" y="182880"/>
             <a:ext cx="10972800" cy="457200"/>
           </a:xfrm>
           <a:prstGeom prst="rect">
@@ -4862,7 +4841,7 @@
           <a:lstStyle/>
           <a:p>
             <a:pPr algn="l">
-              <a:defRPr sz="2000" b="1">
+              <a:defRPr sz="1800" b="1">
                 <a:solidFill>
                   <a:srgbClr val="FFFFFF"/>
                 </a:solidFill>
@@ -4891,50 +4870,14 @@
         </p:blipFill>
         <p:spPr>
           <a:xfrm>
-            <a:off x="457200" y="1097280"/>
-            <a:ext cx="11247120" cy="5578647"/>
+            <a:off x="274320" y="822960"/>
+            <a:ext cx="11612880" cy="5760067"/>
           </a:xfrm>
           <a:prstGeom prst="rect">
             <a:avLst/>
           </a:prstGeom>
         </p:spPr>
       </p:pic>
-      <p:sp>
-        <p:nvSpPr>
-          <p:cNvPr id="5" name="TextBox 4"/>
-          <p:cNvSpPr txBox="1"/>
-          <p:nvPr/>
-        </p:nvSpPr>
-        <p:spPr>
-          <a:xfrm>
-            <a:off x="457200" y="6035040"/>
-            <a:ext cx="10972800" cy="548640"/>
-          </a:xfrm>
-          <a:prstGeom prst="rect">
-            <a:avLst/>
-          </a:prstGeom>
-          <a:noFill/>
-        </p:spPr>
-        <p:txBody>
-          <a:bodyPr wrap="square">
-            <a:spAutoFit/>
-          </a:bodyPr>
-          <a:lstStyle/>
-          <a:p>
-            <a:pPr algn="ctr">
-              <a:defRPr sz="1100" b="0">
-                <a:solidFill>
-                  <a:srgbClr val="44546A"/>
-                </a:solidFill>
-                <a:latin typeface="Arial"/>
-              </a:defRPr>
-            </a:pPr>
-            <a:r>
-              <a:t>Figure 1: Steps 2–4 of the old journey — where most PMM content lived — now happen inside an AI's context window in seconds.</a:t>
-            </a:r>
-          </a:p>
-        </p:txBody>
-      </p:sp>
     </p:spTree>
   </p:cSld>
   <p:clrMapOvr>
@@ -4962,7 +4905,7 @@
         <p:spPr>
           <a:xfrm>
             <a:off x="0" y="0"/>
-            <a:ext cx="12191695" cy="914400"/>
+            <a:ext cx="12191695" cy="731520"/>
           </a:xfrm>
           <a:prstGeom prst="rect">
             <a:avLst/>
@@ -5004,7 +4947,7 @@
         </p:nvSpPr>
         <p:spPr>
           <a:xfrm>
-            <a:off x="457200" y="228600"/>
+            <a:off x="457200" y="182880"/>
             <a:ext cx="10972800" cy="457200"/>
           </a:xfrm>
           <a:prstGeom prst="rect">
@@ -5019,7 +4962,7 @@
           <a:lstStyle/>
           <a:p>
             <a:pPr algn="l">
-              <a:defRPr sz="2000" b="1">
+              <a:defRPr sz="1800" b="1">
                 <a:solidFill>
                   <a:srgbClr val="FFFFFF"/>
                 </a:solidFill>
@@ -5027,675 +4970,35 @@
               </a:defRPr>
             </a:pPr>
             <a:r>
-              <a:t>THE THREE ERAS OF ENTERPRISE DATA</a:t>
-            </a:r>
-          </a:p>
-        </p:txBody>
-      </p:sp>
-      <p:sp>
-        <p:nvSpPr>
-          <p:cNvPr id="4" name="Rectangle 3"/>
-          <p:cNvSpPr/>
-          <p:nvPr/>
-        </p:nvSpPr>
-        <p:spPr>
-          <a:xfrm>
-            <a:off x="457200" y="1188720"/>
-            <a:ext cx="3657600" cy="4389120"/>
-          </a:xfrm>
-          <a:prstGeom prst="rect">
-            <a:avLst/>
-          </a:prstGeom>
-          <a:solidFill>
-            <a:srgbClr val="44546A"/>
-          </a:solidFill>
-          <a:ln>
-            <a:noFill/>
-          </a:ln>
-        </p:spPr>
-        <p:style>
-          <a:lnRef idx="1">
-            <a:schemeClr val="accent1"/>
-          </a:lnRef>
-          <a:fillRef idx="3">
-            <a:schemeClr val="accent1"/>
-          </a:fillRef>
-          <a:effectRef idx="2">
-            <a:schemeClr val="accent1"/>
-          </a:effectRef>
-          <a:fontRef idx="minor">
-            <a:schemeClr val="lt1"/>
-          </a:fontRef>
-        </p:style>
-        <p:txBody>
-          <a:bodyPr rtlCol="0" anchor="ctr"/>
-          <a:lstStyle/>
-          <a:p>
-            <a:pPr algn="ctr"/>
-          </a:p>
-        </p:txBody>
-      </p:sp>
-      <p:sp>
-        <p:nvSpPr>
-          <p:cNvPr id="5" name="TextBox 4"/>
-          <p:cNvSpPr txBox="1"/>
-          <p:nvPr/>
-        </p:nvSpPr>
-        <p:spPr>
-          <a:xfrm>
-            <a:off x="640080" y="1371600"/>
-            <a:ext cx="3291840" cy="457200"/>
-          </a:xfrm>
-          <a:prstGeom prst="rect">
-            <a:avLst/>
-          </a:prstGeom>
-          <a:noFill/>
-        </p:spPr>
-        <p:txBody>
-          <a:bodyPr wrap="square">
-            <a:spAutoFit/>
-          </a:bodyPr>
-          <a:lstStyle/>
-          <a:p>
-            <a:pPr algn="l">
-              <a:defRPr sz="1200" b="1">
-                <a:solidFill>
-                  <a:srgbClr val="FFFFFF"/>
-                </a:solidFill>
-                <a:latin typeface="Arial"/>
-              </a:defRPr>
-            </a:pPr>
-            <a:r>
-              <a:t>ERA 1</a:t>
-            </a:r>
-          </a:p>
-        </p:txBody>
-      </p:sp>
-      <p:sp>
-        <p:nvSpPr>
-          <p:cNvPr id="6" name="TextBox 5"/>
-          <p:cNvSpPr txBox="1"/>
-          <p:nvPr/>
-        </p:nvSpPr>
-        <p:spPr>
-          <a:xfrm>
-            <a:off x="640080" y="1828800"/>
-            <a:ext cx="3291840" cy="640080"/>
-          </a:xfrm>
-          <a:prstGeom prst="rect">
-            <a:avLst/>
-          </a:prstGeom>
-          <a:noFill/>
-        </p:spPr>
-        <p:txBody>
-          <a:bodyPr wrap="square">
-            <a:spAutoFit/>
-          </a:bodyPr>
-          <a:lstStyle/>
-          <a:p>
-            <a:pPr algn="l">
-              <a:defRPr sz="2000" b="1">
-                <a:solidFill>
-                  <a:srgbClr val="FFFFFF"/>
-                </a:solidFill>
-                <a:latin typeface="Arial"/>
-              </a:defRPr>
-            </a:pPr>
-            <a:r>
-              <a:t>Data Warehouse</a:t>
-            </a:r>
-          </a:p>
-        </p:txBody>
-      </p:sp>
-      <p:sp>
-        <p:nvSpPr>
-          <p:cNvPr id="7" name="TextBox 6"/>
-          <p:cNvSpPr txBox="1"/>
-          <p:nvPr/>
-        </p:nvSpPr>
-        <p:spPr>
-          <a:xfrm>
-            <a:off x="640080" y="2377440"/>
-            <a:ext cx="3291840" cy="457200"/>
-          </a:xfrm>
-          <a:prstGeom prst="rect">
-            <a:avLst/>
-          </a:prstGeom>
-          <a:noFill/>
-        </p:spPr>
-        <p:txBody>
-          <a:bodyPr wrap="square">
-            <a:spAutoFit/>
-          </a:bodyPr>
-          <a:lstStyle/>
-          <a:p>
-            <a:pPr algn="l">
-              <a:defRPr sz="1400" b="0">
-                <a:solidFill>
-                  <a:srgbClr val="E7E6E6"/>
-                </a:solidFill>
-                <a:latin typeface="Arial"/>
-              </a:defRPr>
-            </a:pPr>
-            <a:r>
-              <a:t>Age of Reports</a:t>
-            </a:r>
-          </a:p>
-        </p:txBody>
-      </p:sp>
-      <p:sp>
-        <p:nvSpPr>
-          <p:cNvPr id="8" name="TextBox 7"/>
-          <p:cNvSpPr txBox="1"/>
-          <p:nvPr/>
-        </p:nvSpPr>
-        <p:spPr>
-          <a:xfrm>
-            <a:off x="640080" y="3017520"/>
-            <a:ext cx="3291840" cy="2286000"/>
-          </a:xfrm>
-          <a:prstGeom prst="rect">
-            <a:avLst/>
-          </a:prstGeom>
-          <a:noFill/>
-        </p:spPr>
-        <p:txBody>
-          <a:bodyPr wrap="square">
-            <a:spAutoFit/>
-          </a:bodyPr>
-          <a:lstStyle/>
-          <a:p>
-            <a:pPr algn="l">
-              <a:defRPr sz="1200" b="0">
-                <a:solidFill>
-                  <a:srgbClr val="FFFFFF"/>
-                </a:solidFill>
-                <a:latin typeface="Arial"/>
-              </a:defRPr>
-            </a:pPr>
-            <a:r>
-              <a:t>ETL batch jobs. Static deliverables.</a:t>
-            </a:r>
-            <a:br/>
-            <a:r>
-              <a:t>Quarterly reviews. Slow data,</a:t>
-            </a:r>
-            <a:br/>
-            <a:r>
-              <a:t>slow marketing, slow buyers.</a:t>
-            </a:r>
-          </a:p>
-        </p:txBody>
-      </p:sp>
-      <p:sp>
-        <p:nvSpPr>
-          <p:cNvPr id="9" name="Rectangle 8"/>
-          <p:cNvSpPr/>
-          <p:nvPr/>
-        </p:nvSpPr>
-        <p:spPr>
-          <a:xfrm>
-            <a:off x="4297680" y="1188720"/>
-            <a:ext cx="3657600" cy="4389120"/>
-          </a:xfrm>
-          <a:prstGeom prst="rect">
-            <a:avLst/>
-          </a:prstGeom>
-          <a:solidFill>
-            <a:srgbClr val="4472C4"/>
-          </a:solidFill>
-          <a:ln>
-            <a:noFill/>
-          </a:ln>
-        </p:spPr>
-        <p:style>
-          <a:lnRef idx="1">
-            <a:schemeClr val="accent1"/>
-          </a:lnRef>
-          <a:fillRef idx="3">
-            <a:schemeClr val="accent1"/>
-          </a:fillRef>
-          <a:effectRef idx="2">
-            <a:schemeClr val="accent1"/>
-          </a:effectRef>
-          <a:fontRef idx="minor">
-            <a:schemeClr val="lt1"/>
-          </a:fontRef>
-        </p:style>
-        <p:txBody>
-          <a:bodyPr rtlCol="0" anchor="ctr"/>
-          <a:lstStyle/>
-          <a:p>
-            <a:pPr algn="ctr"/>
-          </a:p>
-        </p:txBody>
-      </p:sp>
-      <p:sp>
-        <p:nvSpPr>
-          <p:cNvPr id="10" name="TextBox 9"/>
-          <p:cNvSpPr txBox="1"/>
-          <p:nvPr/>
-        </p:nvSpPr>
-        <p:spPr>
-          <a:xfrm>
-            <a:off x="4480560" y="1371600"/>
-            <a:ext cx="3291840" cy="457200"/>
-          </a:xfrm>
-          <a:prstGeom prst="rect">
-            <a:avLst/>
-          </a:prstGeom>
-          <a:noFill/>
-        </p:spPr>
-        <p:txBody>
-          <a:bodyPr wrap="square">
-            <a:spAutoFit/>
-          </a:bodyPr>
-          <a:lstStyle/>
-          <a:p>
-            <a:pPr algn="l">
-              <a:defRPr sz="1200" b="1">
-                <a:solidFill>
-                  <a:srgbClr val="FFFFFF"/>
-                </a:solidFill>
-                <a:latin typeface="Arial"/>
-              </a:defRPr>
-            </a:pPr>
-            <a:r>
-              <a:t>ERA 2</a:t>
-            </a:r>
-          </a:p>
-        </p:txBody>
-      </p:sp>
-      <p:sp>
-        <p:nvSpPr>
-          <p:cNvPr id="11" name="TextBox 10"/>
-          <p:cNvSpPr txBox="1"/>
-          <p:nvPr/>
-        </p:nvSpPr>
-        <p:spPr>
-          <a:xfrm>
-            <a:off x="4480560" y="1828800"/>
-            <a:ext cx="3291840" cy="640080"/>
-          </a:xfrm>
-          <a:prstGeom prst="rect">
-            <a:avLst/>
-          </a:prstGeom>
-          <a:noFill/>
-        </p:spPr>
-        <p:txBody>
-          <a:bodyPr wrap="square">
-            <a:spAutoFit/>
-          </a:bodyPr>
-          <a:lstStyle/>
-          <a:p>
-            <a:pPr algn="l">
-              <a:defRPr sz="2000" b="1">
-                <a:solidFill>
-                  <a:srgbClr val="FFFFFF"/>
-                </a:solidFill>
-                <a:latin typeface="Arial"/>
-              </a:defRPr>
-            </a:pPr>
-            <a:r>
-              <a:t>Data Lake</a:t>
-            </a:r>
-          </a:p>
-        </p:txBody>
-      </p:sp>
-      <p:sp>
-        <p:nvSpPr>
-          <p:cNvPr id="12" name="TextBox 11"/>
-          <p:cNvSpPr txBox="1"/>
-          <p:nvPr/>
-        </p:nvSpPr>
-        <p:spPr>
-          <a:xfrm>
-            <a:off x="4480560" y="2377440"/>
-            <a:ext cx="3291840" cy="457200"/>
-          </a:xfrm>
-          <a:prstGeom prst="rect">
-            <a:avLst/>
-          </a:prstGeom>
-          <a:noFill/>
-        </p:spPr>
-        <p:txBody>
-          <a:bodyPr wrap="square">
-            <a:spAutoFit/>
-          </a:bodyPr>
-          <a:lstStyle/>
-          <a:p>
-            <a:pPr algn="l">
-              <a:defRPr sz="1400" b="0">
-                <a:solidFill>
-                  <a:srgbClr val="FFC000"/>
-                </a:solidFill>
-                <a:latin typeface="Arial"/>
-              </a:defRPr>
-            </a:pPr>
-            <a:r>
-              <a:t>Age of Unification</a:t>
-            </a:r>
-          </a:p>
-        </p:txBody>
-      </p:sp>
-      <p:sp>
-        <p:nvSpPr>
-          <p:cNvPr id="13" name="TextBox 12"/>
-          <p:cNvSpPr txBox="1"/>
-          <p:nvPr/>
-        </p:nvSpPr>
-        <p:spPr>
-          <a:xfrm>
-            <a:off x="4480560" y="3017520"/>
-            <a:ext cx="3291840" cy="2286000"/>
-          </a:xfrm>
-          <a:prstGeom prst="rect">
-            <a:avLst/>
-          </a:prstGeom>
-          <a:noFill/>
-        </p:spPr>
-        <p:txBody>
-          <a:bodyPr wrap="square">
-            <a:spAutoFit/>
-          </a:bodyPr>
-          <a:lstStyle/>
-          <a:p>
-            <a:pPr algn="l">
-              <a:defRPr sz="1200" b="0">
-                <a:solidFill>
-                  <a:srgbClr val="FFFFFF"/>
-                </a:solidFill>
-                <a:latin typeface="Arial"/>
-              </a:defRPr>
-            </a:pPr>
-            <a:r>
-              <a:t>CDP era. Customer strategy.</a:t>
-            </a:r>
-            <a:br/>
-            <a:r>
-              <a:t>Journey mapping. Win/loss analysis.</a:t>
-            </a:r>
-            <a:br/>
-            <a:r>
-              <a:t>"A CDP knows your customer."</a:t>
-            </a:r>
-          </a:p>
-        </p:txBody>
-      </p:sp>
-      <p:sp>
-        <p:nvSpPr>
-          <p:cNvPr id="14" name="Rectangle 13"/>
-          <p:cNvSpPr/>
-          <p:nvPr/>
-        </p:nvSpPr>
-        <p:spPr>
-          <a:xfrm>
-            <a:off x="8138160" y="1188720"/>
-            <a:ext cx="3657600" cy="4389120"/>
-          </a:xfrm>
-          <a:prstGeom prst="rect">
-            <a:avLst/>
-          </a:prstGeom>
-          <a:solidFill>
-            <a:srgbClr val="ED7D31"/>
-          </a:solidFill>
-          <a:ln>
-            <a:noFill/>
-          </a:ln>
-        </p:spPr>
-        <p:style>
-          <a:lnRef idx="1">
-            <a:schemeClr val="accent1"/>
-          </a:lnRef>
-          <a:fillRef idx="3">
-            <a:schemeClr val="accent1"/>
-          </a:fillRef>
-          <a:effectRef idx="2">
-            <a:schemeClr val="accent1"/>
-          </a:effectRef>
-          <a:fontRef idx="minor">
-            <a:schemeClr val="lt1"/>
-          </a:fontRef>
-        </p:style>
-        <p:txBody>
-          <a:bodyPr rtlCol="0" anchor="ctr"/>
-          <a:lstStyle/>
-          <a:p>
-            <a:pPr algn="ctr"/>
-          </a:p>
-        </p:txBody>
-      </p:sp>
-      <p:sp>
-        <p:nvSpPr>
-          <p:cNvPr id="15" name="TextBox 14"/>
-          <p:cNvSpPr txBox="1"/>
-          <p:nvPr/>
-        </p:nvSpPr>
-        <p:spPr>
-          <a:xfrm>
-            <a:off x="8321040" y="1371600"/>
-            <a:ext cx="3291840" cy="457200"/>
-          </a:xfrm>
-          <a:prstGeom prst="rect">
-            <a:avLst/>
-          </a:prstGeom>
-          <a:noFill/>
-        </p:spPr>
-        <p:txBody>
-          <a:bodyPr wrap="square">
-            <a:spAutoFit/>
-          </a:bodyPr>
-          <a:lstStyle/>
-          <a:p>
-            <a:pPr algn="l">
-              <a:defRPr sz="1200" b="1">
-                <a:solidFill>
-                  <a:srgbClr val="FFFFFF"/>
-                </a:solidFill>
-                <a:latin typeface="Arial"/>
-              </a:defRPr>
-            </a:pPr>
-            <a:r>
-              <a:t>ERA 3</a:t>
-            </a:r>
-          </a:p>
-        </p:txBody>
-      </p:sp>
-      <p:sp>
-        <p:nvSpPr>
-          <p:cNvPr id="16" name="TextBox 15"/>
-          <p:cNvSpPr txBox="1"/>
-          <p:nvPr/>
-        </p:nvSpPr>
-        <p:spPr>
-          <a:xfrm>
-            <a:off x="8321040" y="1828800"/>
-            <a:ext cx="3291840" cy="640080"/>
-          </a:xfrm>
-          <a:prstGeom prst="rect">
-            <a:avLst/>
-          </a:prstGeom>
-          <a:noFill/>
-        </p:spPr>
-        <p:txBody>
-          <a:bodyPr wrap="square">
-            <a:spAutoFit/>
-          </a:bodyPr>
-          <a:lstStyle/>
-          <a:p>
-            <a:pPr algn="l">
-              <a:defRPr sz="2000" b="1">
-                <a:solidFill>
-                  <a:srgbClr val="FFFFFF"/>
-                </a:solidFill>
-                <a:latin typeface="Arial"/>
-              </a:defRPr>
-            </a:pPr>
-            <a:r>
-              <a:t>Data Fabric</a:t>
-            </a:r>
-          </a:p>
-        </p:txBody>
-      </p:sp>
-      <p:sp>
-        <p:nvSpPr>
-          <p:cNvPr id="17" name="TextBox 16"/>
-          <p:cNvSpPr txBox="1"/>
-          <p:nvPr/>
-        </p:nvSpPr>
-        <p:spPr>
-          <a:xfrm>
-            <a:off x="8321040" y="2377440"/>
-            <a:ext cx="3291840" cy="457200"/>
-          </a:xfrm>
-          <a:prstGeom prst="rect">
-            <a:avLst/>
-          </a:prstGeom>
-          <a:noFill/>
-        </p:spPr>
-        <p:txBody>
-          <a:bodyPr wrap="square">
-            <a:spAutoFit/>
-          </a:bodyPr>
-          <a:lstStyle/>
-          <a:p>
-            <a:pPr algn="l">
-              <a:defRPr sz="1400" b="0">
-                <a:solidFill>
-                  <a:srgbClr val="FFC000"/>
-                </a:solidFill>
-                <a:latin typeface="Arial"/>
-              </a:defRPr>
-            </a:pPr>
-            <a:r>
-              <a:t>Age of Agents</a:t>
-            </a:r>
-          </a:p>
-        </p:txBody>
-      </p:sp>
-      <p:sp>
-        <p:nvSpPr>
-          <p:cNvPr id="18" name="TextBox 17"/>
-          <p:cNvSpPr txBox="1"/>
-          <p:nvPr/>
-        </p:nvSpPr>
-        <p:spPr>
-          <a:xfrm>
-            <a:off x="8321040" y="3017520"/>
-            <a:ext cx="3291840" cy="2286000"/>
-          </a:xfrm>
-          <a:prstGeom prst="rect">
-            <a:avLst/>
-          </a:prstGeom>
-          <a:noFill/>
-        </p:spPr>
-        <p:txBody>
-          <a:bodyPr wrap="square">
-            <a:spAutoFit/>
-          </a:bodyPr>
-          <a:lstStyle/>
-          <a:p>
-            <a:pPr algn="l">
-              <a:defRPr sz="1200" b="0">
-                <a:solidFill>
-                  <a:srgbClr val="FFFFFF"/>
-                </a:solidFill>
-                <a:latin typeface="Arial"/>
-              </a:defRPr>
-            </a:pPr>
-            <a:r>
-              <a:t>Agentic AI. Federated metadata.</a:t>
-            </a:r>
-            <a:br/>
-            <a:r>
-              <a:t>Agents that monitor, adjust, generate.</a:t>
-            </a:r>
-            <a:br/>
-            <a:r>
-              <a:t>"An AMP knows your business."</a:t>
-            </a:r>
-          </a:p>
-        </p:txBody>
-      </p:sp>
-      <p:sp>
-        <p:nvSpPr>
-          <p:cNvPr id="19" name="Rectangle 18"/>
-          <p:cNvSpPr/>
-          <p:nvPr/>
-        </p:nvSpPr>
-        <p:spPr>
-          <a:xfrm>
-            <a:off x="457200" y="5760720"/>
-            <a:ext cx="11247120" cy="731520"/>
-          </a:xfrm>
-          <a:prstGeom prst="rect">
-            <a:avLst/>
-          </a:prstGeom>
-          <a:solidFill>
-            <a:srgbClr val="E7E6E6"/>
-          </a:solidFill>
-          <a:ln>
-            <a:noFill/>
-          </a:ln>
-        </p:spPr>
-        <p:style>
-          <a:lnRef idx="1">
-            <a:schemeClr val="accent1"/>
-          </a:lnRef>
-          <a:fillRef idx="3">
-            <a:schemeClr val="accent1"/>
-          </a:fillRef>
-          <a:effectRef idx="2">
-            <a:schemeClr val="accent1"/>
-          </a:effectRef>
-          <a:fontRef idx="minor">
-            <a:schemeClr val="lt1"/>
-          </a:fontRef>
-        </p:style>
-        <p:txBody>
-          <a:bodyPr rtlCol="0" anchor="ctr"/>
-          <a:lstStyle/>
-          <a:p>
-            <a:pPr algn="ctr"/>
-          </a:p>
-        </p:txBody>
-      </p:sp>
-      <p:sp>
-        <p:nvSpPr>
-          <p:cNvPr id="20" name="TextBox 19"/>
-          <p:cNvSpPr txBox="1"/>
-          <p:nvPr/>
-        </p:nvSpPr>
-        <p:spPr>
-          <a:xfrm>
-            <a:off x="640080" y="5897880"/>
-            <a:ext cx="10881360" cy="548640"/>
-          </a:xfrm>
-          <a:prstGeom prst="rect">
-            <a:avLst/>
-          </a:prstGeom>
-          <a:noFill/>
-        </p:spPr>
-        <p:txBody>
-          <a:bodyPr wrap="square">
-            <a:spAutoFit/>
-          </a:bodyPr>
-          <a:lstStyle/>
-          <a:p>
-            <a:pPr algn="ctr">
-              <a:defRPr sz="1400" b="1">
-                <a:solidFill>
-                  <a:srgbClr val="44546A"/>
-                </a:solidFill>
-                <a:latin typeface="Arial"/>
-              </a:defRPr>
-            </a:pPr>
-            <a:r>
-              <a:t>A DMP knew your audience. A CDP knew your customer. An AMP knows your business.</a:t>
-            </a:r>
-          </a:p>
-        </p:txBody>
-      </p:sp>
+              <a:t>THE VISIBILITY GAP</a:t>
+            </a:r>
+          </a:p>
+        </p:txBody>
+      </p:sp>
+      <p:pic>
+        <p:nvPicPr>
+          <p:cNvPr id="4" name="Picture 3" descr="fig2-visibility-gap.png"/>
+          <p:cNvPicPr>
+            <a:picLocks noChangeAspect="1"/>
+          </p:cNvPicPr>
+          <p:nvPr/>
+        </p:nvPicPr>
+        <p:blipFill>
+          <a:blip r:embed="rId2"/>
+          <a:stretch>
+            <a:fillRect/>
+          </a:stretch>
+        </p:blipFill>
+        <p:spPr>
+          <a:xfrm>
+            <a:off x="274320" y="822960"/>
+            <a:ext cx="11612880" cy="5271925"/>
+          </a:xfrm>
+          <a:prstGeom prst="rect">
+            <a:avLst/>
+          </a:prstGeom>
+        </p:spPr>
+      </p:pic>
     </p:spTree>
   </p:cSld>
   <p:clrMapOvr>
@@ -5723,7 +5026,7 @@
         <p:spPr>
           <a:xfrm>
             <a:off x="0" y="0"/>
-            <a:ext cx="12191695" cy="914400"/>
+            <a:ext cx="12191695" cy="731520"/>
           </a:xfrm>
           <a:prstGeom prst="rect">
             <a:avLst/>
@@ -5765,7 +5068,7 @@
         </p:nvSpPr>
         <p:spPr>
           <a:xfrm>
-            <a:off x="457200" y="228600"/>
+            <a:off x="457200" y="182880"/>
             <a:ext cx="10972800" cy="457200"/>
           </a:xfrm>
           <a:prstGeom prst="rect">
@@ -5780,7 +5083,7 @@
           <a:lstStyle/>
           <a:p>
             <a:pPr algn="l">
-              <a:defRPr sz="2000" b="1">
+              <a:defRPr sz="1800" b="1">
                 <a:solidFill>
                   <a:srgbClr val="FFFFFF"/>
                 </a:solidFill>
@@ -5788,14 +5091,14 @@
               </a:defRPr>
             </a:pPr>
             <a:r>
-              <a:t>THE VISIBILITY GAP</a:t>
+              <a:t>FROM SEO TO GEO</a:t>
             </a:r>
           </a:p>
         </p:txBody>
       </p:sp>
       <p:pic>
         <p:nvPicPr>
-          <p:cNvPr id="4" name="Picture 3" descr="fig2-visibility-gap.png"/>
+          <p:cNvPr id="4" name="Picture 3" descr="fig3-seo-to-geo.png"/>
           <p:cNvPicPr>
             <a:picLocks noChangeAspect="1"/>
           </p:cNvPicPr>
@@ -5809,8 +5112,8 @@
         </p:blipFill>
         <p:spPr>
           <a:xfrm>
-            <a:off x="457200" y="1005840"/>
-            <a:ext cx="11247120" cy="5105880"/>
+            <a:off x="914400" y="822960"/>
+            <a:ext cx="10058400" cy="5489172"/>
           </a:xfrm>
           <a:prstGeom prst="rect">
             <a:avLst/>
@@ -5819,14 +5122,57 @@
       </p:pic>
       <p:sp>
         <p:nvSpPr>
-          <p:cNvPr id="5" name="TextBox 4"/>
+          <p:cNvPr id="5" name="Rectangle 4"/>
+          <p:cNvSpPr/>
+          <p:nvPr/>
+        </p:nvSpPr>
+        <p:spPr>
+          <a:xfrm>
+            <a:off x="457200" y="5303520"/>
+            <a:ext cx="11247120" cy="1097280"/>
+          </a:xfrm>
+          <a:prstGeom prst="rect">
+            <a:avLst/>
+          </a:prstGeom>
+          <a:solidFill>
+            <a:srgbClr val="70AD47"/>
+          </a:solidFill>
+          <a:ln>
+            <a:noFill/>
+          </a:ln>
+        </p:spPr>
+        <p:style>
+          <a:lnRef idx="1">
+            <a:schemeClr val="accent1"/>
+          </a:lnRef>
+          <a:fillRef idx="3">
+            <a:schemeClr val="accent1"/>
+          </a:fillRef>
+          <a:effectRef idx="2">
+            <a:schemeClr val="accent1"/>
+          </a:effectRef>
+          <a:fontRef idx="minor">
+            <a:schemeClr val="lt1"/>
+          </a:fontRef>
+        </p:style>
+        <p:txBody>
+          <a:bodyPr rtlCol="0" anchor="ctr"/>
+          <a:lstStyle/>
+          <a:p>
+            <a:pPr algn="ctr"/>
+          </a:p>
+        </p:txBody>
+      </p:sp>
+      <p:sp>
+        <p:nvSpPr>
+          <p:cNvPr id="6" name="TextBox 5"/>
           <p:cNvSpPr txBox="1"/>
           <p:nvPr/>
         </p:nvSpPr>
         <p:spPr>
           <a:xfrm>
-            <a:off x="457200" y="5943600"/>
-            <a:ext cx="10972800" cy="548640"/>
+            <a:off x="640080" y="5440680"/>
+            <a:ext cx="10972800" cy="365760"/>
           </a:xfrm>
           <a:prstGeom prst="rect">
             <a:avLst/>
@@ -5839,16 +5185,52 @@
           </a:bodyPr>
           <a:lstStyle/>
           <a:p>
-            <a:pPr algn="ctr">
+            <a:pPr algn="l">
+              <a:defRPr sz="1200" b="1">
+                <a:solidFill>
+                  <a:srgbClr val="FFFFFF"/>
+                </a:solidFill>
+                <a:latin typeface="Arial"/>
+              </a:defRPr>
+            </a:pPr>
+            <a:r>
+              <a:t>The Audit (Do This Week)</a:t>
+            </a:r>
+          </a:p>
+        </p:txBody>
+      </p:sp>
+      <p:sp>
+        <p:nvSpPr>
+          <p:cNvPr id="7" name="TextBox 6"/>
+          <p:cNvSpPr txBox="1"/>
+          <p:nvPr/>
+        </p:nvSpPr>
+        <p:spPr>
+          <a:xfrm>
+            <a:off x="640080" y="5806440"/>
+            <a:ext cx="10881360" cy="548640"/>
+          </a:xfrm>
+          <a:prstGeom prst="rect">
+            <a:avLst/>
+          </a:prstGeom>
+          <a:noFill/>
+        </p:spPr>
+        <p:txBody>
+          <a:bodyPr wrap="square">
+            <a:spAutoFit/>
+          </a:bodyPr>
+          <a:lstStyle/>
+          <a:p>
+            <a:pPr algn="l">
               <a:defRPr sz="1100" b="0">
                 <a:solidFill>
-                  <a:srgbClr val="44546A"/>
+                  <a:srgbClr val="FFFFFF"/>
                 </a:solidFill>
                 <a:latin typeface="Arial"/>
               </a:defRPr>
             </a:pPr>
             <a:r>
-              <a:t>Figure 2: The Visibility Gap is not a technology problem — it is a prioritization problem.</a:t>
+              <a:t>Open Claude, ChatGPT, or Perplexity. Ask it to evaluate vendors in your category. See if your company appears.</a:t>
             </a:r>
           </a:p>
         </p:txBody>
@@ -5880,7 +5262,7 @@
         <p:spPr>
           <a:xfrm>
             <a:off x="0" y="0"/>
-            <a:ext cx="12191695" cy="914400"/>
+            <a:ext cx="12191695" cy="731520"/>
           </a:xfrm>
           <a:prstGeom prst="rect">
             <a:avLst/>
@@ -5922,7 +5304,7 @@
         </p:nvSpPr>
         <p:spPr>
           <a:xfrm>
-            <a:off x="457200" y="228600"/>
+            <a:off x="457200" y="182880"/>
             <a:ext cx="10972800" cy="457200"/>
           </a:xfrm>
           <a:prstGeom prst="rect">
@@ -5937,7 +5319,7 @@
           <a:lstStyle/>
           <a:p>
             <a:pPr algn="l">
-              <a:defRPr sz="2000" b="1">
+              <a:defRPr sz="1800" b="1">
                 <a:solidFill>
                   <a:srgbClr val="FFFFFF"/>
                 </a:solidFill>
@@ -5945,50 +5327,14 @@
               </a:defRPr>
             </a:pPr>
             <a:r>
-              <a:t>FROM SEO TO GEO</a:t>
-            </a:r>
-          </a:p>
-        </p:txBody>
-      </p:sp>
-      <p:sp>
-        <p:nvSpPr>
-          <p:cNvPr id="4" name="TextBox 3"/>
-          <p:cNvSpPr txBox="1"/>
-          <p:nvPr/>
-        </p:nvSpPr>
-        <p:spPr>
-          <a:xfrm>
-            <a:off x="457200" y="1005840"/>
-            <a:ext cx="10972800" cy="457200"/>
-          </a:xfrm>
-          <a:prstGeom prst="rect">
-            <a:avLst/>
-          </a:prstGeom>
-          <a:noFill/>
-        </p:spPr>
-        <p:txBody>
-          <a:bodyPr wrap="square">
-            <a:spAutoFit/>
-          </a:bodyPr>
-          <a:lstStyle/>
-          <a:p>
-            <a:pPr algn="l">
-              <a:defRPr sz="1400" b="0">
-                <a:solidFill>
-                  <a:srgbClr val="44546A"/>
-                </a:solidFill>
-                <a:latin typeface="Arial"/>
-              </a:defRPr>
-            </a:pPr>
-            <a:r>
-              <a:t>Generative Engine Optimization — the signals are fundamentally different.</a:t>
+              <a:t>THE NEW AWARENESS STACK</a:t>
             </a:r>
           </a:p>
         </p:txBody>
       </p:sp>
       <p:pic>
         <p:nvPicPr>
-          <p:cNvPr id="5" name="Picture 4" descr="fig3-seo-to-geo.png"/>
+          <p:cNvPr id="4" name="Picture 3" descr="fig5-awareness-stack.png"/>
           <p:cNvPicPr>
             <a:picLocks noChangeAspect="1"/>
           </p:cNvPicPr>
@@ -6002,129 +5348,14 @@
         </p:blipFill>
         <p:spPr>
           <a:xfrm>
-            <a:off x="1371600" y="1463040"/>
-            <a:ext cx="9144000" cy="4990157"/>
+            <a:off x="274320" y="822960"/>
+            <a:ext cx="11612880" cy="5140299"/>
           </a:xfrm>
           <a:prstGeom prst="rect">
             <a:avLst/>
           </a:prstGeom>
         </p:spPr>
       </p:pic>
-      <p:sp>
-        <p:nvSpPr>
-          <p:cNvPr id="6" name="Rectangle 5"/>
-          <p:cNvSpPr/>
-          <p:nvPr/>
-        </p:nvSpPr>
-        <p:spPr>
-          <a:xfrm>
-            <a:off x="457200" y="5303520"/>
-            <a:ext cx="11247120" cy="1097280"/>
-          </a:xfrm>
-          <a:prstGeom prst="rect">
-            <a:avLst/>
-          </a:prstGeom>
-          <a:solidFill>
-            <a:srgbClr val="70AD47"/>
-          </a:solidFill>
-          <a:ln>
-            <a:noFill/>
-          </a:ln>
-        </p:spPr>
-        <p:style>
-          <a:lnRef idx="1">
-            <a:schemeClr val="accent1"/>
-          </a:lnRef>
-          <a:fillRef idx="3">
-            <a:schemeClr val="accent1"/>
-          </a:fillRef>
-          <a:effectRef idx="2">
-            <a:schemeClr val="accent1"/>
-          </a:effectRef>
-          <a:fontRef idx="minor">
-            <a:schemeClr val="lt1"/>
-          </a:fontRef>
-        </p:style>
-        <p:txBody>
-          <a:bodyPr rtlCol="0" anchor="ctr"/>
-          <a:lstStyle/>
-          <a:p>
-            <a:pPr algn="ctr"/>
-          </a:p>
-        </p:txBody>
-      </p:sp>
-      <p:sp>
-        <p:nvSpPr>
-          <p:cNvPr id="7" name="TextBox 6"/>
-          <p:cNvSpPr txBox="1"/>
-          <p:nvPr/>
-        </p:nvSpPr>
-        <p:spPr>
-          <a:xfrm>
-            <a:off x="640080" y="5440680"/>
-            <a:ext cx="10972800" cy="365760"/>
-          </a:xfrm>
-          <a:prstGeom prst="rect">
-            <a:avLst/>
-          </a:prstGeom>
-          <a:noFill/>
-        </p:spPr>
-        <p:txBody>
-          <a:bodyPr wrap="square">
-            <a:spAutoFit/>
-          </a:bodyPr>
-          <a:lstStyle/>
-          <a:p>
-            <a:pPr algn="l">
-              <a:defRPr sz="1200" b="1">
-                <a:solidFill>
-                  <a:srgbClr val="FFFFFF"/>
-                </a:solidFill>
-                <a:latin typeface="Arial"/>
-              </a:defRPr>
-            </a:pPr>
-            <a:r>
-              <a:t>The Audit (Do This Week)</a:t>
-            </a:r>
-          </a:p>
-        </p:txBody>
-      </p:sp>
-      <p:sp>
-        <p:nvSpPr>
-          <p:cNvPr id="8" name="TextBox 7"/>
-          <p:cNvSpPr txBox="1"/>
-          <p:nvPr/>
-        </p:nvSpPr>
-        <p:spPr>
-          <a:xfrm>
-            <a:off x="640080" y="5806440"/>
-            <a:ext cx="10881360" cy="548640"/>
-          </a:xfrm>
-          <a:prstGeom prst="rect">
-            <a:avLst/>
-          </a:prstGeom>
-          <a:noFill/>
-        </p:spPr>
-        <p:txBody>
-          <a:bodyPr wrap="square">
-            <a:spAutoFit/>
-          </a:bodyPr>
-          <a:lstStyle/>
-          <a:p>
-            <a:pPr algn="l">
-              <a:defRPr sz="1100" b="0">
-                <a:solidFill>
-                  <a:srgbClr val="FFFFFF"/>
-                </a:solidFill>
-                <a:latin typeface="Arial"/>
-              </a:defRPr>
-            </a:pPr>
-            <a:r>
-              <a:t>Open Claude, ChatGPT, or Perplexity. Ask it to evaluate vendors in your category. See if your company appears. That 60-second exercise tells you more about your GEO readiness than any consultant's report.</a:t>
-            </a:r>
-          </a:p>
-        </p:txBody>
-      </p:sp>
     </p:spTree>
   </p:cSld>
   <p:clrMapOvr>
@@ -6152,7 +5383,7 @@
         <p:spPr>
           <a:xfrm>
             <a:off x="0" y="0"/>
-            <a:ext cx="12191695" cy="914400"/>
+            <a:ext cx="12191695" cy="731520"/>
           </a:xfrm>
           <a:prstGeom prst="rect">
             <a:avLst/>
@@ -6194,7 +5425,7 @@
         </p:nvSpPr>
         <p:spPr>
           <a:xfrm>
-            <a:off x="457200" y="228600"/>
+            <a:off x="457200" y="182880"/>
             <a:ext cx="10972800" cy="457200"/>
           </a:xfrm>
           <a:prstGeom prst="rect">
@@ -6209,7 +5440,7 @@
           <a:lstStyle/>
           <a:p>
             <a:pPr algn="l">
-              <a:defRPr sz="2000" b="1">
+              <a:defRPr sz="1800" b="1">
                 <a:solidFill>
                   <a:srgbClr val="FFFFFF"/>
                 </a:solidFill>
@@ -6217,785 +5448,35 @@
               </a:defRPr>
             </a:pPr>
             <a:r>
-              <a:t>THE PRAGMATIC FRAMEWORK MEETS THE MACHINE</a:t>
-            </a:r>
-          </a:p>
-        </p:txBody>
-      </p:sp>
-      <p:sp>
-        <p:nvSpPr>
-          <p:cNvPr id="4" name="TextBox 3"/>
-          <p:cNvSpPr txBox="1"/>
-          <p:nvPr/>
-        </p:nvSpPr>
-        <p:spPr>
-          <a:xfrm>
-            <a:off x="457200" y="1005840"/>
-            <a:ext cx="10972800" cy="548640"/>
-          </a:xfrm>
-          <a:prstGeom prst="rect">
-            <a:avLst/>
-          </a:prstGeom>
-          <a:noFill/>
-        </p:spPr>
-        <p:txBody>
-          <a:bodyPr wrap="square">
-            <a:spAutoFit/>
-          </a:bodyPr>
-          <a:lstStyle/>
-          <a:p>
-            <a:pPr algn="l">
-              <a:defRPr sz="1400" b="0">
-                <a:solidFill>
-                  <a:srgbClr val="44546A"/>
-                </a:solidFill>
-                <a:latin typeface="Arial"/>
-              </a:defRPr>
-            </a:pPr>
-            <a:r>
-              <a:t>37 boxes. Three clusters. One question: what happens when AI agents become part of the team?</a:t>
-            </a:r>
-          </a:p>
-        </p:txBody>
-      </p:sp>
-      <p:sp>
-        <p:nvSpPr>
-          <p:cNvPr id="5" name="Rectangle 4"/>
-          <p:cNvSpPr/>
-          <p:nvPr/>
-        </p:nvSpPr>
-        <p:spPr>
-          <a:xfrm>
-            <a:off x="457200" y="1737360"/>
-            <a:ext cx="3657600" cy="4114800"/>
-          </a:xfrm>
-          <a:prstGeom prst="rect">
-            <a:avLst/>
-          </a:prstGeom>
-          <a:solidFill>
-            <a:srgbClr val="E7E6E6"/>
-          </a:solidFill>
-          <a:ln>
-            <a:noFill/>
-          </a:ln>
-        </p:spPr>
-        <p:style>
-          <a:lnRef idx="1">
-            <a:schemeClr val="accent1"/>
-          </a:lnRef>
-          <a:fillRef idx="3">
-            <a:schemeClr val="accent1"/>
-          </a:fillRef>
-          <a:effectRef idx="2">
-            <a:schemeClr val="accent1"/>
-          </a:effectRef>
-          <a:fontRef idx="minor">
-            <a:schemeClr val="lt1"/>
-          </a:fontRef>
-        </p:style>
-        <p:txBody>
-          <a:bodyPr rtlCol="0" anchor="ctr"/>
-          <a:lstStyle/>
-          <a:p>
-            <a:pPr algn="ctr"/>
-          </a:p>
-        </p:txBody>
-      </p:sp>
-      <p:sp>
-        <p:nvSpPr>
-          <p:cNvPr id="6" name="TextBox 5"/>
-          <p:cNvSpPr txBox="1"/>
-          <p:nvPr/>
-        </p:nvSpPr>
-        <p:spPr>
-          <a:xfrm>
-            <a:off x="640080" y="1920240"/>
-            <a:ext cx="3291840" cy="365760"/>
-          </a:xfrm>
-          <a:prstGeom prst="rect">
-            <a:avLst/>
-          </a:prstGeom>
-          <a:noFill/>
-        </p:spPr>
-        <p:txBody>
-          <a:bodyPr wrap="square">
-            <a:spAutoFit/>
-          </a:bodyPr>
-          <a:lstStyle/>
-          <a:p>
-            <a:pPr algn="l">
-              <a:defRPr sz="1000" b="1">
-                <a:solidFill>
-                  <a:srgbClr val="44546A"/>
-                </a:solidFill>
-                <a:latin typeface="Arial"/>
-              </a:defRPr>
-            </a:pPr>
-            <a:r>
-              <a:t>CLUSTER 1</a:t>
-            </a:r>
-          </a:p>
-        </p:txBody>
-      </p:sp>
-      <p:sp>
-        <p:nvSpPr>
-          <p:cNvPr id="7" name="TextBox 6"/>
-          <p:cNvSpPr txBox="1"/>
-          <p:nvPr/>
-        </p:nvSpPr>
-        <p:spPr>
-          <a:xfrm>
-            <a:off x="640080" y="2286000"/>
-            <a:ext cx="3291840" cy="457200"/>
-          </a:xfrm>
-          <a:prstGeom prst="rect">
-            <a:avLst/>
-          </a:prstGeom>
-          <a:noFill/>
-        </p:spPr>
-        <p:txBody>
-          <a:bodyPr wrap="square">
-            <a:spAutoFit/>
-          </a:bodyPr>
-          <a:lstStyle/>
-          <a:p>
-            <a:pPr algn="l">
-              <a:defRPr sz="1800" b="1">
-                <a:solidFill>
-                  <a:srgbClr val="44546A"/>
-                </a:solidFill>
-                <a:latin typeface="Arial"/>
-              </a:defRPr>
-            </a:pPr>
-            <a:r>
-              <a:t>Automated</a:t>
-            </a:r>
-          </a:p>
-        </p:txBody>
-      </p:sp>
-      <p:sp>
-        <p:nvSpPr>
-          <p:cNvPr id="8" name="TextBox 7"/>
-          <p:cNvSpPr txBox="1"/>
-          <p:nvPr/>
-        </p:nvSpPr>
-        <p:spPr>
-          <a:xfrm>
-            <a:off x="640080" y="2834640"/>
-            <a:ext cx="3291840" cy="1188720"/>
-          </a:xfrm>
-          <a:prstGeom prst="rect">
-            <a:avLst/>
-          </a:prstGeom>
-          <a:noFill/>
-        </p:spPr>
-        <p:txBody>
-          <a:bodyPr wrap="square">
-            <a:spAutoFit/>
-          </a:bodyPr>
-          <a:lstStyle/>
-          <a:p>
-            <a:pPr algn="l">
-              <a:defRPr sz="1100" b="0">
-                <a:solidFill>
-                  <a:srgbClr val="44546A"/>
-                </a:solidFill>
-                <a:latin typeface="Arial"/>
-              </a:defRPr>
-            </a:pPr>
-            <a:r>
-              <a:t>Market sizing, derivative content,</a:t>
-            </a:r>
-            <a:br/>
-            <a:r>
-              <a:t>event logistics, sales tools production.</a:t>
-            </a:r>
-            <a:br/>
-            <a:r>
-              <a:t>Agents do the majority today.</a:t>
-            </a:r>
-          </a:p>
-        </p:txBody>
-      </p:sp>
-      <p:sp>
-        <p:nvSpPr>
-          <p:cNvPr id="9" name="Rectangle 8"/>
-          <p:cNvSpPr/>
-          <p:nvPr/>
-        </p:nvSpPr>
-        <p:spPr>
-          <a:xfrm>
-            <a:off x="640080" y="4023360"/>
-            <a:ext cx="3291840" cy="18288"/>
-          </a:xfrm>
-          <a:prstGeom prst="rect">
-            <a:avLst/>
-          </a:prstGeom>
-          <a:solidFill>
-            <a:srgbClr val="ED7D31"/>
-          </a:solidFill>
-          <a:ln>
-            <a:noFill/>
-          </a:ln>
-        </p:spPr>
-        <p:style>
-          <a:lnRef idx="1">
-            <a:schemeClr val="accent1"/>
-          </a:lnRef>
-          <a:fillRef idx="3">
-            <a:schemeClr val="accent1"/>
-          </a:fillRef>
-          <a:effectRef idx="2">
-            <a:schemeClr val="accent1"/>
-          </a:effectRef>
-          <a:fontRef idx="minor">
-            <a:schemeClr val="lt1"/>
-          </a:fontRef>
-        </p:style>
-        <p:txBody>
-          <a:bodyPr rtlCol="0" anchor="ctr"/>
-          <a:lstStyle/>
-          <a:p>
-            <a:pPr algn="ctr"/>
-          </a:p>
-        </p:txBody>
-      </p:sp>
-      <p:sp>
-        <p:nvSpPr>
-          <p:cNvPr id="10" name="TextBox 9"/>
-          <p:cNvSpPr txBox="1"/>
-          <p:nvPr/>
-        </p:nvSpPr>
-        <p:spPr>
-          <a:xfrm>
-            <a:off x="640080" y="4206240"/>
-            <a:ext cx="3291840" cy="1371600"/>
-          </a:xfrm>
-          <a:prstGeom prst="rect">
-            <a:avLst/>
-          </a:prstGeom>
-          <a:noFill/>
-        </p:spPr>
-        <p:txBody>
-          <a:bodyPr wrap="square">
-            <a:spAutoFit/>
-          </a:bodyPr>
-          <a:lstStyle/>
-          <a:p>
-            <a:pPr algn="l">
-              <a:defRPr sz="1000" b="0">
-                <a:solidFill>
-                  <a:srgbClr val="44546A"/>
-                </a:solidFill>
-                <a:latin typeface="Arial"/>
-              </a:defRPr>
-            </a:pPr>
-            <a:r>
-              <a:t>70% time savings on production.</a:t>
-            </a:r>
-            <a:br/>
-            <a:r>
-              <a:t>If your value is producing artifacts,</a:t>
-            </a:r>
-            <a:br/>
-            <a:r>
-              <a:t>the automation wave is not your friend.</a:t>
-            </a:r>
-          </a:p>
-        </p:txBody>
-      </p:sp>
-      <p:sp>
-        <p:nvSpPr>
-          <p:cNvPr id="11" name="Rectangle 10"/>
-          <p:cNvSpPr/>
-          <p:nvPr/>
-        </p:nvSpPr>
-        <p:spPr>
-          <a:xfrm>
-            <a:off x="4297680" y="1737360"/>
-            <a:ext cx="3657600" cy="4114800"/>
-          </a:xfrm>
-          <a:prstGeom prst="rect">
-            <a:avLst/>
-          </a:prstGeom>
-          <a:solidFill>
-            <a:srgbClr val="4472C4"/>
-          </a:solidFill>
-          <a:ln>
-            <a:noFill/>
-          </a:ln>
-        </p:spPr>
-        <p:style>
-          <a:lnRef idx="1">
-            <a:schemeClr val="accent1"/>
-          </a:lnRef>
-          <a:fillRef idx="3">
-            <a:schemeClr val="accent1"/>
-          </a:fillRef>
-          <a:effectRef idx="2">
-            <a:schemeClr val="accent1"/>
-          </a:effectRef>
-          <a:fontRef idx="minor">
-            <a:schemeClr val="lt1"/>
-          </a:fontRef>
-        </p:style>
-        <p:txBody>
-          <a:bodyPr rtlCol="0" anchor="ctr"/>
-          <a:lstStyle/>
-          <a:p>
-            <a:pPr algn="ctr"/>
-          </a:p>
-        </p:txBody>
-      </p:sp>
-      <p:sp>
-        <p:nvSpPr>
-          <p:cNvPr id="12" name="TextBox 11"/>
-          <p:cNvSpPr txBox="1"/>
-          <p:nvPr/>
-        </p:nvSpPr>
-        <p:spPr>
-          <a:xfrm>
-            <a:off x="4480560" y="1920240"/>
-            <a:ext cx="3291840" cy="365760"/>
-          </a:xfrm>
-          <a:prstGeom prst="rect">
-            <a:avLst/>
-          </a:prstGeom>
-          <a:noFill/>
-        </p:spPr>
-        <p:txBody>
-          <a:bodyPr wrap="square">
-            <a:spAutoFit/>
-          </a:bodyPr>
-          <a:lstStyle/>
-          <a:p>
-            <a:pPr algn="l">
-              <a:defRPr sz="1000" b="1">
-                <a:solidFill>
-                  <a:srgbClr val="FFFFFF"/>
-                </a:solidFill>
-                <a:latin typeface="Arial"/>
-              </a:defRPr>
-            </a:pPr>
-            <a:r>
-              <a:t>CLUSTER 2</a:t>
-            </a:r>
-          </a:p>
-        </p:txBody>
-      </p:sp>
-      <p:sp>
-        <p:nvSpPr>
-          <p:cNvPr id="13" name="TextBox 12"/>
-          <p:cNvSpPr txBox="1"/>
-          <p:nvPr/>
-        </p:nvSpPr>
-        <p:spPr>
-          <a:xfrm>
-            <a:off x="4480560" y="2286000"/>
-            <a:ext cx="3291840" cy="457200"/>
-          </a:xfrm>
-          <a:prstGeom prst="rect">
-            <a:avLst/>
-          </a:prstGeom>
-          <a:noFill/>
-        </p:spPr>
-        <p:txBody>
-          <a:bodyPr wrap="square">
-            <a:spAutoFit/>
-          </a:bodyPr>
-          <a:lstStyle/>
-          <a:p>
-            <a:pPr algn="l">
-              <a:defRPr sz="1800" b="1">
-                <a:solidFill>
-                  <a:srgbClr val="FFFFFF"/>
-                </a:solidFill>
-                <a:latin typeface="Arial"/>
-              </a:defRPr>
-            </a:pPr>
-            <a:r>
-              <a:t>Augmented</a:t>
-            </a:r>
-          </a:p>
-        </p:txBody>
-      </p:sp>
-      <p:sp>
-        <p:nvSpPr>
-          <p:cNvPr id="14" name="TextBox 13"/>
-          <p:cNvSpPr txBox="1"/>
-          <p:nvPr/>
-        </p:nvSpPr>
-        <p:spPr>
-          <a:xfrm>
-            <a:off x="4480560" y="2834640"/>
-            <a:ext cx="3291840" cy="1188720"/>
-          </a:xfrm>
-          <a:prstGeom prst="rect">
-            <a:avLst/>
-          </a:prstGeom>
-          <a:noFill/>
-        </p:spPr>
-        <p:txBody>
-          <a:bodyPr wrap="square">
-            <a:spAutoFit/>
-          </a:bodyPr>
-          <a:lstStyle/>
-          <a:p>
-            <a:pPr algn="l">
-              <a:defRPr sz="1100" b="0">
-                <a:solidFill>
-                  <a:srgbClr val="FFFFFF"/>
-                </a:solidFill>
-                <a:latin typeface="Arial"/>
-              </a:defRPr>
-            </a:pPr>
-            <a:r>
-              <a:t>Positioning, win/loss analysis,</a:t>
-            </a:r>
-            <a:br/>
-            <a:r>
-              <a:t>buyer personas, pricing strategy.</a:t>
-            </a:r>
-            <a:br/>
-            <a:r>
-              <a:t>Human essential, agent accelerates.</a:t>
-            </a:r>
-          </a:p>
-        </p:txBody>
-      </p:sp>
-      <p:sp>
-        <p:nvSpPr>
-          <p:cNvPr id="15" name="Rectangle 14"/>
-          <p:cNvSpPr/>
-          <p:nvPr/>
-        </p:nvSpPr>
-        <p:spPr>
-          <a:xfrm>
-            <a:off x="4480560" y="4023360"/>
-            <a:ext cx="3291840" cy="18288"/>
-          </a:xfrm>
-          <a:prstGeom prst="rect">
-            <a:avLst/>
-          </a:prstGeom>
-          <a:solidFill>
-            <a:srgbClr val="FFC000"/>
-          </a:solidFill>
-          <a:ln>
-            <a:noFill/>
-          </a:ln>
-        </p:spPr>
-        <p:style>
-          <a:lnRef idx="1">
-            <a:schemeClr val="accent1"/>
-          </a:lnRef>
-          <a:fillRef idx="3">
-            <a:schemeClr val="accent1"/>
-          </a:fillRef>
-          <a:effectRef idx="2">
-            <a:schemeClr val="accent1"/>
-          </a:effectRef>
-          <a:fontRef idx="minor">
-            <a:schemeClr val="lt1"/>
-          </a:fontRef>
-        </p:style>
-        <p:txBody>
-          <a:bodyPr rtlCol="0" anchor="ctr"/>
-          <a:lstStyle/>
-          <a:p>
-            <a:pPr algn="ctr"/>
-          </a:p>
-        </p:txBody>
-      </p:sp>
-      <p:sp>
-        <p:nvSpPr>
-          <p:cNvPr id="16" name="TextBox 15"/>
-          <p:cNvSpPr txBox="1"/>
-          <p:nvPr/>
-        </p:nvSpPr>
-        <p:spPr>
-          <a:xfrm>
-            <a:off x="4480560" y="4206240"/>
-            <a:ext cx="3291840" cy="1371600"/>
-          </a:xfrm>
-          <a:prstGeom prst="rect">
-            <a:avLst/>
-          </a:prstGeom>
-          <a:noFill/>
-        </p:spPr>
-        <p:txBody>
-          <a:bodyPr wrap="square">
-            <a:spAutoFit/>
-          </a:bodyPr>
-          <a:lstStyle/>
-          <a:p>
-            <a:pPr algn="l">
-              <a:defRPr sz="1000" b="0">
-                <a:solidFill>
-                  <a:srgbClr val="FFFFFF"/>
-                </a:solidFill>
-                <a:latin typeface="Arial"/>
-              </a:defRPr>
-            </a:pPr>
-            <a:r>
-              <a:t>Human-agent team is so much better</a:t>
-            </a:r>
-            <a:br/>
-            <a:r>
-              <a:t>that operating without agents</a:t>
-            </a:r>
-            <a:br/>
-            <a:r>
-              <a:t>becomes a competitive disadvantage.</a:t>
-            </a:r>
-          </a:p>
-        </p:txBody>
-      </p:sp>
-      <p:sp>
-        <p:nvSpPr>
-          <p:cNvPr id="17" name="Rectangle 16"/>
-          <p:cNvSpPr/>
-          <p:nvPr/>
-        </p:nvSpPr>
-        <p:spPr>
-          <a:xfrm>
-            <a:off x="8138160" y="1737360"/>
-            <a:ext cx="3657600" cy="4114800"/>
-          </a:xfrm>
-          <a:prstGeom prst="rect">
-            <a:avLst/>
-          </a:prstGeom>
-          <a:solidFill>
-            <a:srgbClr val="ED7D31"/>
-          </a:solidFill>
-          <a:ln>
-            <a:noFill/>
-          </a:ln>
-        </p:spPr>
-        <p:style>
-          <a:lnRef idx="1">
-            <a:schemeClr val="accent1"/>
-          </a:lnRef>
-          <a:fillRef idx="3">
-            <a:schemeClr val="accent1"/>
-          </a:fillRef>
-          <a:effectRef idx="2">
-            <a:schemeClr val="accent1"/>
-          </a:effectRef>
-          <a:fontRef idx="minor">
-            <a:schemeClr val="lt1"/>
-          </a:fontRef>
-        </p:style>
-        <p:txBody>
-          <a:bodyPr rtlCol="0" anchor="ctr"/>
-          <a:lstStyle/>
-          <a:p>
-            <a:pPr algn="ctr"/>
-          </a:p>
-        </p:txBody>
-      </p:sp>
-      <p:sp>
-        <p:nvSpPr>
-          <p:cNvPr id="18" name="TextBox 17"/>
-          <p:cNvSpPr txBox="1"/>
-          <p:nvPr/>
-        </p:nvSpPr>
-        <p:spPr>
-          <a:xfrm>
-            <a:off x="8321040" y="1920240"/>
-            <a:ext cx="3291840" cy="365760"/>
-          </a:xfrm>
-          <a:prstGeom prst="rect">
-            <a:avLst/>
-          </a:prstGeom>
-          <a:noFill/>
-        </p:spPr>
-        <p:txBody>
-          <a:bodyPr wrap="square">
-            <a:spAutoFit/>
-          </a:bodyPr>
-          <a:lstStyle/>
-          <a:p>
-            <a:pPr algn="l">
-              <a:defRPr sz="1000" b="1">
-                <a:solidFill>
-                  <a:srgbClr val="FFFFFF"/>
-                </a:solidFill>
-                <a:latin typeface="Arial"/>
-              </a:defRPr>
-            </a:pPr>
-            <a:r>
-              <a:t>CLUSTER 3</a:t>
-            </a:r>
-          </a:p>
-        </p:txBody>
-      </p:sp>
-      <p:sp>
-        <p:nvSpPr>
-          <p:cNvPr id="19" name="TextBox 18"/>
-          <p:cNvSpPr txBox="1"/>
-          <p:nvPr/>
-        </p:nvSpPr>
-        <p:spPr>
-          <a:xfrm>
-            <a:off x="8321040" y="2286000"/>
-            <a:ext cx="3291840" cy="457200"/>
-          </a:xfrm>
-          <a:prstGeom prst="rect">
-            <a:avLst/>
-          </a:prstGeom>
-          <a:noFill/>
-        </p:spPr>
-        <p:txBody>
-          <a:bodyPr wrap="square">
-            <a:spAutoFit/>
-          </a:bodyPr>
-          <a:lstStyle/>
-          <a:p>
-            <a:pPr algn="l">
-              <a:defRPr sz="1800" b="1">
-                <a:solidFill>
-                  <a:srgbClr val="FFFFFF"/>
-                </a:solidFill>
-                <a:latin typeface="Arial"/>
-              </a:defRPr>
-            </a:pPr>
-            <a:r>
-              <a:t>Elevated</a:t>
-            </a:r>
-          </a:p>
-        </p:txBody>
-      </p:sp>
-      <p:sp>
-        <p:nvSpPr>
-          <p:cNvPr id="20" name="TextBox 19"/>
-          <p:cNvSpPr txBox="1"/>
-          <p:nvPr/>
-        </p:nvSpPr>
-        <p:spPr>
-          <a:xfrm>
-            <a:off x="8321040" y="2834640"/>
-            <a:ext cx="3291840" cy="1188720"/>
-          </a:xfrm>
-          <a:prstGeom prst="rect">
-            <a:avLst/>
-          </a:prstGeom>
-          <a:noFill/>
-        </p:spPr>
-        <p:txBody>
-          <a:bodyPr wrap="square">
-            <a:spAutoFit/>
-          </a:bodyPr>
-          <a:lstStyle/>
-          <a:p>
-            <a:pPr algn="l">
-              <a:defRPr sz="1100" b="0">
-                <a:solidFill>
-                  <a:srgbClr val="FFFFFF"/>
-                </a:solidFill>
-                <a:latin typeface="Arial"/>
-              </a:defRPr>
-            </a:pPr>
-            <a:r>
-              <a:t>Stakeholder management, customer</a:t>
-            </a:r>
-            <a:br/>
-            <a:r>
-              <a:t>empathy, thought leadership.</a:t>
-            </a:r>
-            <a:br/>
-            <a:r>
-              <a:t>Irreducibly human.</a:t>
-            </a:r>
-          </a:p>
-        </p:txBody>
-      </p:sp>
-      <p:sp>
-        <p:nvSpPr>
-          <p:cNvPr id="21" name="Rectangle 20"/>
-          <p:cNvSpPr/>
-          <p:nvPr/>
-        </p:nvSpPr>
-        <p:spPr>
-          <a:xfrm>
-            <a:off x="8321040" y="4023360"/>
-            <a:ext cx="3291840" cy="18288"/>
-          </a:xfrm>
-          <a:prstGeom prst="rect">
-            <a:avLst/>
-          </a:prstGeom>
-          <a:solidFill>
-            <a:srgbClr val="FFC000"/>
-          </a:solidFill>
-          <a:ln>
-            <a:noFill/>
-          </a:ln>
-        </p:spPr>
-        <p:style>
-          <a:lnRef idx="1">
-            <a:schemeClr val="accent1"/>
-          </a:lnRef>
-          <a:fillRef idx="3">
-            <a:schemeClr val="accent1"/>
-          </a:fillRef>
-          <a:effectRef idx="2">
-            <a:schemeClr val="accent1"/>
-          </a:effectRef>
-          <a:fontRef idx="minor">
-            <a:schemeClr val="lt1"/>
-          </a:fontRef>
-        </p:style>
-        <p:txBody>
-          <a:bodyPr rtlCol="0" anchor="ctr"/>
-          <a:lstStyle/>
-          <a:p>
-            <a:pPr algn="ctr"/>
-          </a:p>
-        </p:txBody>
-      </p:sp>
-      <p:sp>
-        <p:nvSpPr>
-          <p:cNvPr id="22" name="TextBox 21"/>
-          <p:cNvSpPr txBox="1"/>
-          <p:nvPr/>
-        </p:nvSpPr>
-        <p:spPr>
-          <a:xfrm>
-            <a:off x="8321040" y="4206240"/>
-            <a:ext cx="3291840" cy="1371600"/>
-          </a:xfrm>
-          <a:prstGeom prst="rect">
-            <a:avLst/>
-          </a:prstGeom>
-          <a:noFill/>
-        </p:spPr>
-        <p:txBody>
-          <a:bodyPr wrap="square">
-            <a:spAutoFit/>
-          </a:bodyPr>
-          <a:lstStyle/>
-          <a:p>
-            <a:pPr algn="l">
-              <a:defRPr sz="1000" b="0">
-                <a:solidFill>
-                  <a:srgbClr val="FFFFFF"/>
-                </a:solidFill>
-                <a:latin typeface="Arial"/>
-              </a:defRPr>
-            </a:pPr>
-            <a:r>
-              <a:t>These activities become MORE important</a:t>
-            </a:r>
-            <a:br/>
-            <a:r>
-              <a:t>precisely because machines can't do them.</a:t>
-            </a:r>
-            <a:br/>
-            <a:r>
-              <a:t>This is where careers are built.</a:t>
-            </a:r>
-          </a:p>
-        </p:txBody>
-      </p:sp>
+              <a:t>THE TIERED LAUNCH MODEL</a:t>
+            </a:r>
+          </a:p>
+        </p:txBody>
+      </p:sp>
+      <p:pic>
+        <p:nvPicPr>
+          <p:cNvPr id="4" name="Picture 3" descr="fig6-tiered-launch.png"/>
+          <p:cNvPicPr>
+            <a:picLocks noChangeAspect="1"/>
+          </p:cNvPicPr>
+          <p:nvPr/>
+        </p:nvPicPr>
+        <p:blipFill>
+          <a:blip r:embed="rId2"/>
+          <a:stretch>
+            <a:fillRect/>
+          </a:stretch>
+        </p:blipFill>
+        <p:spPr>
+          <a:xfrm>
+            <a:off x="274320" y="1097280"/>
+            <a:ext cx="11612880" cy="4295643"/>
+          </a:xfrm>
+          <a:prstGeom prst="rect">
+            <a:avLst/>
+          </a:prstGeom>
+        </p:spPr>
+      </p:pic>
     </p:spTree>
   </p:cSld>
   <p:clrMapOvr>
@@ -7023,7 +5504,7 @@
         <p:spPr>
           <a:xfrm>
             <a:off x="0" y="0"/>
-            <a:ext cx="12191695" cy="914400"/>
+            <a:ext cx="12191695" cy="548640"/>
           </a:xfrm>
           <a:prstGeom prst="rect">
             <a:avLst/>
@@ -7065,8 +5546,8 @@
         </p:nvSpPr>
         <p:spPr>
           <a:xfrm>
-            <a:off x="457200" y="228600"/>
-            <a:ext cx="10972800" cy="457200"/>
+            <a:off x="457200" y="109728"/>
+            <a:ext cx="10972800" cy="365760"/>
           </a:xfrm>
           <a:prstGeom prst="rect">
             <a:avLst/>
@@ -7080,7 +5561,7 @@
           <a:lstStyle/>
           <a:p>
             <a:pPr algn="l">
-              <a:defRPr sz="2000" b="1">
+              <a:defRPr sz="1600" b="1">
                 <a:solidFill>
                   <a:srgbClr val="FFFFFF"/>
                 </a:solidFill>
@@ -7088,7 +5569,7 @@
               </a:defRPr>
             </a:pPr>
             <a:r>
-              <a:t>THE CURRICULUM ARCHITECTURE</a:t>
+              <a:t>THE PRAGMATIC 37 → AGENTIC FUNNEL MAP</a:t>
             </a:r>
           </a:p>
         </p:txBody>
@@ -7109,50 +5590,14 @@
         </p:blipFill>
         <p:spPr>
           <a:xfrm>
-            <a:off x="457200" y="1005840"/>
-            <a:ext cx="11247120" cy="8009374"/>
+            <a:off x="182880" y="594360"/>
+            <a:ext cx="11795760" cy="8400075"/>
           </a:xfrm>
           <a:prstGeom prst="rect">
             <a:avLst/>
           </a:prstGeom>
         </p:spPr>
       </p:pic>
-      <p:sp>
-        <p:nvSpPr>
-          <p:cNvPr id="5" name="TextBox 4"/>
-          <p:cNvSpPr txBox="1"/>
-          <p:nvPr/>
-        </p:nvSpPr>
-        <p:spPr>
-          <a:xfrm>
-            <a:off x="457200" y="6035040"/>
-            <a:ext cx="10972800" cy="548640"/>
-          </a:xfrm>
-          <a:prstGeom prst="rect">
-            <a:avLst/>
-          </a:prstGeom>
-          <a:noFill/>
-        </p:spPr>
-        <p:txBody>
-          <a:bodyPr wrap="square">
-            <a:spAutoFit/>
-          </a:bodyPr>
-          <a:lstStyle/>
-          <a:p>
-            <a:pPr algn="ctr">
-              <a:defRPr sz="1000" b="0">
-                <a:solidFill>
-                  <a:srgbClr val="44546A"/>
-                </a:solidFill>
-                <a:latin typeface="Arial"/>
-              </a:defRPr>
-            </a:pPr>
-            <a:r>
-              <a:t>Figure 4: The Pragmatic 37 → Agentic Funnel Map. All 37 activities mapped to the six-stage funnel, color-coded by Pragmatic category.</a:t>
-            </a:r>
-          </a:p>
-        </p:txBody>
-      </p:sp>
     </p:spTree>
   </p:cSld>
   <p:clrMapOvr>
@@ -7186,7 +5631,7 @@
             <a:avLst/>
           </a:prstGeom>
           <a:solidFill>
-            <a:srgbClr val="ED7D31"/>
+            <a:srgbClr val="44546A"/>
           </a:solidFill>
           <a:ln>
             <a:noFill/>
@@ -7237,7 +5682,7 @@
           <a:lstStyle/>
           <a:p>
             <a:pPr algn="l">
-              <a:defRPr sz="2000" b="1">
+              <a:defRPr sz="1800" b="1">
                 <a:solidFill>
                   <a:srgbClr val="FFFFFF"/>
                 </a:solidFill>
@@ -7245,21 +5690,57 @@
               </a:defRPr>
             </a:pPr>
             <a:r>
-              <a:t>THE 10x THESIS</a:t>
-            </a:r>
-          </a:p>
-        </p:txBody>
-      </p:sp>
-      <p:sp>
-        <p:nvSpPr>
-          <p:cNvPr id="4" name="Rectangle 3"/>
+              <a:t>THE PRAGMATIC FRAMEWORK MEETS THE MACHINE</a:t>
+            </a:r>
+          </a:p>
+        </p:txBody>
+      </p:sp>
+      <p:sp>
+        <p:nvSpPr>
+          <p:cNvPr id="4" name="TextBox 3"/>
+          <p:cNvSpPr txBox="1"/>
+          <p:nvPr/>
+        </p:nvSpPr>
+        <p:spPr>
+          <a:xfrm>
+            <a:off x="457200" y="1005840"/>
+            <a:ext cx="10972800" cy="457200"/>
+          </a:xfrm>
+          <a:prstGeom prst="rect">
+            <a:avLst/>
+          </a:prstGeom>
+          <a:noFill/>
+        </p:spPr>
+        <p:txBody>
+          <a:bodyPr wrap="square">
+            <a:spAutoFit/>
+          </a:bodyPr>
+          <a:lstStyle/>
+          <a:p>
+            <a:pPr algn="l">
+              <a:defRPr sz="1400" b="0">
+                <a:solidFill>
+                  <a:srgbClr val="44546A"/>
+                </a:solidFill>
+                <a:latin typeface="Arial"/>
+              </a:defRPr>
+            </a:pPr>
+            <a:r>
+              <a:t>37 boxes. Three clusters. Which activities survive automation?</a:t>
+            </a:r>
+          </a:p>
+        </p:txBody>
+      </p:sp>
+      <p:sp>
+        <p:nvSpPr>
+          <p:cNvPr id="5" name="Rectangle 4"/>
           <p:cNvSpPr/>
           <p:nvPr/>
         </p:nvSpPr>
         <p:spPr>
           <a:xfrm>
-            <a:off x="457200" y="1188720"/>
-            <a:ext cx="11247120" cy="2286000"/>
+            <a:off x="457200" y="1645920"/>
+            <a:ext cx="3657600" cy="3657600"/>
           </a:xfrm>
           <a:prstGeom prst="rect">
             <a:avLst/>
@@ -7295,14 +5776,14 @@
       </p:sp>
       <p:sp>
         <p:nvSpPr>
-          <p:cNvPr id="5" name="TextBox 4"/>
+          <p:cNvPr id="6" name="TextBox 5"/>
           <p:cNvSpPr txBox="1"/>
           <p:nvPr/>
         </p:nvSpPr>
         <p:spPr>
           <a:xfrm>
-            <a:off x="640080" y="1371600"/>
-            <a:ext cx="10881360" cy="2011680"/>
+            <a:off x="640080" y="1828800"/>
+            <a:ext cx="3291840" cy="365760"/>
           </a:xfrm>
           <a:prstGeom prst="rect">
             <a:avLst/>
@@ -7315,8 +5796,8 @@
           </a:bodyPr>
           <a:lstStyle/>
           <a:p>
-            <a:pPr algn="ctr">
-              <a:defRPr sz="1600" b="0">
+            <a:pPr algn="l">
+              <a:defRPr sz="1000" b="1">
                 <a:solidFill>
                   <a:srgbClr val="44546A"/>
                 </a:solidFill>
@@ -7324,26 +5805,21 @@
               </a:defRPr>
             </a:pPr>
             <a:r>
-              <a:t>A PMM who automates 20 hours a week of Cluster One work and redirects that time into deeper competitive analysis, more thoughtful positioning, and genuine thought leadership is going to outperform a PMM who's still manually updating battlecards.</a:t>
-            </a:r>
-            <a:br/>
-            <a:br/>
-            <a:r>
-              <a:t>Not by 20%. By a factor that justifies the title of this book.</a:t>
-            </a:r>
-          </a:p>
-        </p:txBody>
-      </p:sp>
-      <p:sp>
-        <p:nvSpPr>
-          <p:cNvPr id="6" name="TextBox 5"/>
+              <a:t>CLUSTER 1</a:t>
+            </a:r>
+          </a:p>
+        </p:txBody>
+      </p:sp>
+      <p:sp>
+        <p:nvSpPr>
+          <p:cNvPr id="7" name="TextBox 6"/>
           <p:cNvSpPr txBox="1"/>
           <p:nvPr/>
         </p:nvSpPr>
         <p:spPr>
           <a:xfrm>
-            <a:off x="457200" y="3749039"/>
-            <a:ext cx="10972800" cy="457200"/>
+            <a:off x="640080" y="2194560"/>
+            <a:ext cx="3291840" cy="457200"/>
           </a:xfrm>
           <a:prstGeom prst="rect">
             <a:avLst/>
@@ -7357,7 +5833,7 @@
           <a:lstStyle/>
           <a:p>
             <a:pPr algn="l">
-              <a:defRPr sz="1400" b="1">
+              <a:defRPr sz="1800" b="1">
                 <a:solidFill>
                   <a:srgbClr val="44546A"/>
                 </a:solidFill>
@@ -7365,21 +5841,21 @@
               </a:defRPr>
             </a:pPr>
             <a:r>
-              <a:t>What "10x yourself" actually means:</a:t>
-            </a:r>
-          </a:p>
-        </p:txBody>
-      </p:sp>
-      <p:sp>
-        <p:nvSpPr>
-          <p:cNvPr id="7" name="TextBox 6"/>
+              <a:t>Automated</a:t>
+            </a:r>
+          </a:p>
+        </p:txBody>
+      </p:sp>
+      <p:sp>
+        <p:nvSpPr>
+          <p:cNvPr id="8" name="TextBox 7"/>
           <p:cNvSpPr txBox="1"/>
           <p:nvPr/>
         </p:nvSpPr>
         <p:spPr>
           <a:xfrm>
-            <a:off x="457200" y="4206240"/>
-            <a:ext cx="10972800" cy="457200"/>
+            <a:off x="640080" y="2743200"/>
+            <a:ext cx="3291840" cy="2286000"/>
           </a:xfrm>
           <a:prstGeom prst="rect">
             <a:avLst/>
@@ -7393,29 +5869,81 @@
           <a:lstStyle/>
           <a:p>
             <a:pPr algn="l">
-              <a:defRPr sz="1400" b="0">
-                <a:solidFill>
-                  <a:srgbClr val="8B0000"/>
+              <a:defRPr sz="1200" b="0">
+                <a:solidFill>
+                  <a:srgbClr val="44546A"/>
                 </a:solidFill>
                 <a:latin typeface="Arial"/>
               </a:defRPr>
             </a:pPr>
             <a:r>
-              <a:t>✗  NOT working ten times harder</a:t>
-            </a:r>
-          </a:p>
-        </p:txBody>
-      </p:sp>
-      <p:sp>
-        <p:nvSpPr>
-          <p:cNvPr id="8" name="TextBox 7"/>
+              <a:t>Market sizing, derivative content,</a:t>
+            </a:r>
+            <a:br/>
+            <a:r>
+              <a:t>event logistics, sales tools.</a:t>
+            </a:r>
+            <a:br/>
+            <a:br/>
+            <a:r>
+              <a:t>Agents do the majority today.</a:t>
+            </a:r>
+          </a:p>
+        </p:txBody>
+      </p:sp>
+      <p:sp>
+        <p:nvSpPr>
+          <p:cNvPr id="9" name="Rectangle 8"/>
+          <p:cNvSpPr/>
+          <p:nvPr/>
+        </p:nvSpPr>
+        <p:spPr>
+          <a:xfrm>
+            <a:off x="4297680" y="1645920"/>
+            <a:ext cx="3657600" cy="3657600"/>
+          </a:xfrm>
+          <a:prstGeom prst="rect">
+            <a:avLst/>
+          </a:prstGeom>
+          <a:solidFill>
+            <a:srgbClr val="4472C4"/>
+          </a:solidFill>
+          <a:ln>
+            <a:noFill/>
+          </a:ln>
+        </p:spPr>
+        <p:style>
+          <a:lnRef idx="1">
+            <a:schemeClr val="accent1"/>
+          </a:lnRef>
+          <a:fillRef idx="3">
+            <a:schemeClr val="accent1"/>
+          </a:fillRef>
+          <a:effectRef idx="2">
+            <a:schemeClr val="accent1"/>
+          </a:effectRef>
+          <a:fontRef idx="minor">
+            <a:schemeClr val="lt1"/>
+          </a:fontRef>
+        </p:style>
+        <p:txBody>
+          <a:bodyPr rtlCol="0" anchor="ctr"/>
+          <a:lstStyle/>
+          <a:p>
+            <a:pPr algn="ctr"/>
+          </a:p>
+        </p:txBody>
+      </p:sp>
+      <p:sp>
+        <p:nvSpPr>
+          <p:cNvPr id="10" name="TextBox 9"/>
           <p:cNvSpPr txBox="1"/>
           <p:nvPr/>
         </p:nvSpPr>
         <p:spPr>
           <a:xfrm>
-            <a:off x="457200" y="4663440"/>
-            <a:ext cx="10972800" cy="457200"/>
+            <a:off x="4480560" y="1828800"/>
+            <a:ext cx="3291840" cy="365760"/>
           </a:xfrm>
           <a:prstGeom prst="rect">
             <a:avLst/>
@@ -7429,29 +5957,29 @@
           <a:lstStyle/>
           <a:p>
             <a:pPr algn="l">
-              <a:defRPr sz="1400" b="0">
-                <a:solidFill>
-                  <a:srgbClr val="8B0000"/>
+              <a:defRPr sz="1000" b="1">
+                <a:solidFill>
+                  <a:srgbClr val="FFFFFF"/>
                 </a:solidFill>
                 <a:latin typeface="Arial"/>
               </a:defRPr>
             </a:pPr>
             <a:r>
-              <a:t>✗  NOT working ten times faster</a:t>
-            </a:r>
-          </a:p>
-        </p:txBody>
-      </p:sp>
-      <p:sp>
-        <p:nvSpPr>
-          <p:cNvPr id="9" name="TextBox 8"/>
+              <a:t>CLUSTER 2</a:t>
+            </a:r>
+          </a:p>
+        </p:txBody>
+      </p:sp>
+      <p:sp>
+        <p:nvSpPr>
+          <p:cNvPr id="11" name="TextBox 10"/>
           <p:cNvSpPr txBox="1"/>
           <p:nvPr/>
         </p:nvSpPr>
         <p:spPr>
           <a:xfrm>
-            <a:off x="457200" y="5120640"/>
-            <a:ext cx="10972800" cy="457200"/>
+            <a:off x="4480560" y="2194560"/>
+            <a:ext cx="3291840" cy="457200"/>
           </a:xfrm>
           <a:prstGeom prst="rect">
             <a:avLst/>
@@ -7465,29 +5993,29 @@
           <a:lstStyle/>
           <a:p>
             <a:pPr algn="l">
-              <a:defRPr sz="1400" b="1">
-                <a:solidFill>
-                  <a:srgbClr val="70AD47"/>
+              <a:defRPr sz="1800" b="1">
+                <a:solidFill>
+                  <a:srgbClr val="FFFFFF"/>
                 </a:solidFill>
                 <a:latin typeface="Arial"/>
               </a:defRPr>
             </a:pPr>
             <a:r>
-              <a:t>✓  Operating at a fundamentally different level of strategic impact</a:t>
-            </a:r>
-          </a:p>
-        </p:txBody>
-      </p:sp>
-      <p:sp>
-        <p:nvSpPr>
-          <p:cNvPr id="10" name="TextBox 9"/>
+              <a:t>Augmented</a:t>
+            </a:r>
+          </a:p>
+        </p:txBody>
+      </p:sp>
+      <p:sp>
+        <p:nvSpPr>
+          <p:cNvPr id="12" name="TextBox 11"/>
           <p:cNvSpPr txBox="1"/>
           <p:nvPr/>
         </p:nvSpPr>
         <p:spPr>
           <a:xfrm>
-            <a:off x="457200" y="5669280"/>
-            <a:ext cx="10972800" cy="731520"/>
+            <a:off x="4480560" y="2743200"/>
+            <a:ext cx="3291840" cy="2286000"/>
           </a:xfrm>
           <a:prstGeom prst="rect">
             <a:avLst/>
@@ -7500,8 +6028,256 @@
           </a:bodyPr>
           <a:lstStyle/>
           <a:p>
+            <a:pPr algn="l">
+              <a:defRPr sz="1200" b="0">
+                <a:solidFill>
+                  <a:srgbClr val="FFFFFF"/>
+                </a:solidFill>
+                <a:latin typeface="Arial"/>
+              </a:defRPr>
+            </a:pPr>
+            <a:r>
+              <a:t>Positioning, win/loss analysis,</a:t>
+            </a:r>
+            <a:br/>
+            <a:r>
+              <a:t>buyer personas, pricing.</a:t>
+            </a:r>
+            <a:br/>
+            <a:br/>
+            <a:r>
+              <a:t>Human essential, agent accelerates.</a:t>
+            </a:r>
+          </a:p>
+        </p:txBody>
+      </p:sp>
+      <p:sp>
+        <p:nvSpPr>
+          <p:cNvPr id="13" name="Rectangle 12"/>
+          <p:cNvSpPr/>
+          <p:nvPr/>
+        </p:nvSpPr>
+        <p:spPr>
+          <a:xfrm>
+            <a:off x="8138160" y="1645920"/>
+            <a:ext cx="3657600" cy="3657600"/>
+          </a:xfrm>
+          <a:prstGeom prst="rect">
+            <a:avLst/>
+          </a:prstGeom>
+          <a:solidFill>
+            <a:srgbClr val="ED7D31"/>
+          </a:solidFill>
+          <a:ln>
+            <a:noFill/>
+          </a:ln>
+        </p:spPr>
+        <p:style>
+          <a:lnRef idx="1">
+            <a:schemeClr val="accent1"/>
+          </a:lnRef>
+          <a:fillRef idx="3">
+            <a:schemeClr val="accent1"/>
+          </a:fillRef>
+          <a:effectRef idx="2">
+            <a:schemeClr val="accent1"/>
+          </a:effectRef>
+          <a:fontRef idx="minor">
+            <a:schemeClr val="lt1"/>
+          </a:fontRef>
+        </p:style>
+        <p:txBody>
+          <a:bodyPr rtlCol="0" anchor="ctr"/>
+          <a:lstStyle/>
+          <a:p>
+            <a:pPr algn="ctr"/>
+          </a:p>
+        </p:txBody>
+      </p:sp>
+      <p:sp>
+        <p:nvSpPr>
+          <p:cNvPr id="14" name="TextBox 13"/>
+          <p:cNvSpPr txBox="1"/>
+          <p:nvPr/>
+        </p:nvSpPr>
+        <p:spPr>
+          <a:xfrm>
+            <a:off x="8321040" y="1828800"/>
+            <a:ext cx="3291840" cy="365760"/>
+          </a:xfrm>
+          <a:prstGeom prst="rect">
+            <a:avLst/>
+          </a:prstGeom>
+          <a:noFill/>
+        </p:spPr>
+        <p:txBody>
+          <a:bodyPr wrap="square">
+            <a:spAutoFit/>
+          </a:bodyPr>
+          <a:lstStyle/>
+          <a:p>
+            <a:pPr algn="l">
+              <a:defRPr sz="1000" b="1">
+                <a:solidFill>
+                  <a:srgbClr val="FFFFFF"/>
+                </a:solidFill>
+                <a:latin typeface="Arial"/>
+              </a:defRPr>
+            </a:pPr>
+            <a:r>
+              <a:t>CLUSTER 3</a:t>
+            </a:r>
+          </a:p>
+        </p:txBody>
+      </p:sp>
+      <p:sp>
+        <p:nvSpPr>
+          <p:cNvPr id="15" name="TextBox 14"/>
+          <p:cNvSpPr txBox="1"/>
+          <p:nvPr/>
+        </p:nvSpPr>
+        <p:spPr>
+          <a:xfrm>
+            <a:off x="8321040" y="2194560"/>
+            <a:ext cx="3291840" cy="457200"/>
+          </a:xfrm>
+          <a:prstGeom prst="rect">
+            <a:avLst/>
+          </a:prstGeom>
+          <a:noFill/>
+        </p:spPr>
+        <p:txBody>
+          <a:bodyPr wrap="square">
+            <a:spAutoFit/>
+          </a:bodyPr>
+          <a:lstStyle/>
+          <a:p>
+            <a:pPr algn="l">
+              <a:defRPr sz="1800" b="1">
+                <a:solidFill>
+                  <a:srgbClr val="FFFFFF"/>
+                </a:solidFill>
+                <a:latin typeface="Arial"/>
+              </a:defRPr>
+            </a:pPr>
+            <a:r>
+              <a:t>Elevated</a:t>
+            </a:r>
+          </a:p>
+        </p:txBody>
+      </p:sp>
+      <p:sp>
+        <p:nvSpPr>
+          <p:cNvPr id="16" name="TextBox 15"/>
+          <p:cNvSpPr txBox="1"/>
+          <p:nvPr/>
+        </p:nvSpPr>
+        <p:spPr>
+          <a:xfrm>
+            <a:off x="8321040" y="2743200"/>
+            <a:ext cx="3291840" cy="2286000"/>
+          </a:xfrm>
+          <a:prstGeom prst="rect">
+            <a:avLst/>
+          </a:prstGeom>
+          <a:noFill/>
+        </p:spPr>
+        <p:txBody>
+          <a:bodyPr wrap="square">
+            <a:spAutoFit/>
+          </a:bodyPr>
+          <a:lstStyle/>
+          <a:p>
+            <a:pPr algn="l">
+              <a:defRPr sz="1200" b="0">
+                <a:solidFill>
+                  <a:srgbClr val="FFFFFF"/>
+                </a:solidFill>
+                <a:latin typeface="Arial"/>
+              </a:defRPr>
+            </a:pPr>
+            <a:r>
+              <a:t>Stakeholder management,</a:t>
+            </a:r>
+            <a:br/>
+            <a:r>
+              <a:t>customer empathy, thought leadership.</a:t>
+            </a:r>
+            <a:br/>
+            <a:br/>
+            <a:r>
+              <a:t>Irreducibly human.</a:t>
+            </a:r>
+          </a:p>
+        </p:txBody>
+      </p:sp>
+      <p:sp>
+        <p:nvSpPr>
+          <p:cNvPr id="17" name="Rectangle 16"/>
+          <p:cNvSpPr/>
+          <p:nvPr/>
+        </p:nvSpPr>
+        <p:spPr>
+          <a:xfrm>
+            <a:off x="457200" y="5486400"/>
+            <a:ext cx="11247120" cy="914400"/>
+          </a:xfrm>
+          <a:prstGeom prst="rect">
+            <a:avLst/>
+          </a:prstGeom>
+          <a:solidFill>
+            <a:srgbClr val="E7E6E6"/>
+          </a:solidFill>
+          <a:ln>
+            <a:noFill/>
+          </a:ln>
+        </p:spPr>
+        <p:style>
+          <a:lnRef idx="1">
+            <a:schemeClr val="accent1"/>
+          </a:lnRef>
+          <a:fillRef idx="3">
+            <a:schemeClr val="accent1"/>
+          </a:fillRef>
+          <a:effectRef idx="2">
+            <a:schemeClr val="accent1"/>
+          </a:effectRef>
+          <a:fontRef idx="minor">
+            <a:schemeClr val="lt1"/>
+          </a:fontRef>
+        </p:style>
+        <p:txBody>
+          <a:bodyPr rtlCol="0" anchor="ctr"/>
+          <a:lstStyle/>
+          <a:p>
+            <a:pPr algn="ctr"/>
+          </a:p>
+        </p:txBody>
+      </p:sp>
+      <p:sp>
+        <p:nvSpPr>
+          <p:cNvPr id="18" name="TextBox 17"/>
+          <p:cNvSpPr txBox="1"/>
+          <p:nvPr/>
+        </p:nvSpPr>
+        <p:spPr>
+          <a:xfrm>
+            <a:off x="640080" y="5669280"/>
+            <a:ext cx="10881360" cy="640080"/>
+          </a:xfrm>
+          <a:prstGeom prst="rect">
+            <a:avLst/>
+          </a:prstGeom>
+          <a:noFill/>
+        </p:spPr>
+        <p:txBody>
+          <a:bodyPr wrap="square">
+            <a:spAutoFit/>
+          </a:bodyPr>
+          <a:lstStyle/>
+          <a:p>
             <a:pPr algn="ctr">
-              <a:defRPr sz="1400" b="1">
+              <a:defRPr sz="1200" b="0">
                 <a:solidFill>
                   <a:srgbClr val="44546A"/>
                 </a:solidFill>
@@ -7509,7 +6285,11 @@
               </a:defRPr>
             </a:pPr>
             <a:r>
-              <a:t>You've offloaded the mechanical work to machines built for it — and you're finally free to do the work that only a human can do.</a:t>
+              <a:t>If your value is producing artifacts, the automation wave is not your friend.</a:t>
+            </a:r>
+            <a:br/>
+            <a:r>
+              <a:t>The question: are you directing the agents or being replaced by them?</a:t>
             </a:r>
           </a:p>
         </p:txBody>

</xml_diff>